<commit_message>
Storing Data at Session
</commit_message>
<xml_diff>
--- a/.lessons/25 Fundamental HTTP Session/2 Retrieving Data From Session/1.pptx
+++ b/.lessons/25 Fundamental HTTP Session/2 Retrieving Data From Session/1.pptx
@@ -8,6 +8,13 @@
     <p:sldId id="402" r:id="rId2"/>
     <p:sldId id="403" r:id="rId3"/>
     <p:sldId id="400" r:id="rId4"/>
+    <p:sldId id="404" r:id="rId5"/>
+    <p:sldId id="405" r:id="rId6"/>
+    <p:sldId id="406" r:id="rId7"/>
+    <p:sldId id="407" r:id="rId8"/>
+    <p:sldId id="408" r:id="rId9"/>
+    <p:sldId id="409" r:id="rId10"/>
+    <p:sldId id="410" r:id="rId11"/>
   </p:sldIdLst>
   <p:sldSz cx="12192000" cy="6858000"/>
   <p:notesSz cx="6858000" cy="9144000"/>
@@ -261,7 +268,7 @@
           <a:p>
             <a:fld id="{3E102D2E-813C-461C-9963-687A650C48C0}" type="datetimeFigureOut">
               <a:rPr lang="en-US" smtClean="0"/>
-              <a:t>5/23/2025</a:t>
+              <a:t>5/26/2025</a:t>
             </a:fld>
             <a:endParaRPr lang="en-US"/>
           </a:p>
@@ -459,7 +466,7 @@
           <a:p>
             <a:fld id="{3E102D2E-813C-461C-9963-687A650C48C0}" type="datetimeFigureOut">
               <a:rPr lang="en-US" smtClean="0"/>
-              <a:t>5/23/2025</a:t>
+              <a:t>5/26/2025</a:t>
             </a:fld>
             <a:endParaRPr lang="en-US"/>
           </a:p>
@@ -667,7 +674,7 @@
           <a:p>
             <a:fld id="{3E102D2E-813C-461C-9963-687A650C48C0}" type="datetimeFigureOut">
               <a:rPr lang="en-US" smtClean="0"/>
-              <a:t>5/23/2025</a:t>
+              <a:t>5/26/2025</a:t>
             </a:fld>
             <a:endParaRPr lang="en-US"/>
           </a:p>
@@ -865,7 +872,7 @@
           <a:p>
             <a:fld id="{3E102D2E-813C-461C-9963-687A650C48C0}" type="datetimeFigureOut">
               <a:rPr lang="en-US" smtClean="0"/>
-              <a:t>5/23/2025</a:t>
+              <a:t>5/26/2025</a:t>
             </a:fld>
             <a:endParaRPr lang="en-US"/>
           </a:p>
@@ -1140,7 +1147,7 @@
           <a:p>
             <a:fld id="{3E102D2E-813C-461C-9963-687A650C48C0}" type="datetimeFigureOut">
               <a:rPr lang="en-US" smtClean="0"/>
-              <a:t>5/23/2025</a:t>
+              <a:t>5/26/2025</a:t>
             </a:fld>
             <a:endParaRPr lang="en-US"/>
           </a:p>
@@ -1405,7 +1412,7 @@
           <a:p>
             <a:fld id="{3E102D2E-813C-461C-9963-687A650C48C0}" type="datetimeFigureOut">
               <a:rPr lang="en-US" smtClean="0"/>
-              <a:t>5/23/2025</a:t>
+              <a:t>5/26/2025</a:t>
             </a:fld>
             <a:endParaRPr lang="en-US"/>
           </a:p>
@@ -1817,7 +1824,7 @@
           <a:p>
             <a:fld id="{3E102D2E-813C-461C-9963-687A650C48C0}" type="datetimeFigureOut">
               <a:rPr lang="en-US" smtClean="0"/>
-              <a:t>5/23/2025</a:t>
+              <a:t>5/26/2025</a:t>
             </a:fld>
             <a:endParaRPr lang="en-US"/>
           </a:p>
@@ -1958,7 +1965,7 @@
           <a:p>
             <a:fld id="{3E102D2E-813C-461C-9963-687A650C48C0}" type="datetimeFigureOut">
               <a:rPr lang="en-US" smtClean="0"/>
-              <a:t>5/23/2025</a:t>
+              <a:t>5/26/2025</a:t>
             </a:fld>
             <a:endParaRPr lang="en-US"/>
           </a:p>
@@ -2071,7 +2078,7 @@
           <a:p>
             <a:fld id="{3E102D2E-813C-461C-9963-687A650C48C0}" type="datetimeFigureOut">
               <a:rPr lang="en-US" smtClean="0"/>
-              <a:t>5/23/2025</a:t>
+              <a:t>5/26/2025</a:t>
             </a:fld>
             <a:endParaRPr lang="en-US"/>
           </a:p>
@@ -2382,7 +2389,7 @@
           <a:p>
             <a:fld id="{3E102D2E-813C-461C-9963-687A650C48C0}" type="datetimeFigureOut">
               <a:rPr lang="en-US" smtClean="0"/>
-              <a:t>5/23/2025</a:t>
+              <a:t>5/26/2025</a:t>
             </a:fld>
             <a:endParaRPr lang="en-US"/>
           </a:p>
@@ -2670,7 +2677,7 @@
           <a:p>
             <a:fld id="{3E102D2E-813C-461C-9963-687A650C48C0}" type="datetimeFigureOut">
               <a:rPr lang="en-US" smtClean="0"/>
-              <a:t>5/23/2025</a:t>
+              <a:t>5/26/2025</a:t>
             </a:fld>
             <a:endParaRPr lang="en-US"/>
           </a:p>
@@ -2911,7 +2918,7 @@
           <a:p>
             <a:fld id="{3E102D2E-813C-461C-9963-687A650C48C0}" type="datetimeFigureOut">
               <a:rPr lang="en-US" smtClean="0"/>
-              <a:t>5/23/2025</a:t>
+              <a:t>5/26/2025</a:t>
             </a:fld>
             <a:endParaRPr lang="en-US"/>
           </a:p>
@@ -3349,6 +3356,705 @@
         <p:spPr>
           <a:xfrm>
             <a:off x="217714" y="255046"/>
+            <a:ext cx="11756571" cy="5875134"/>
+          </a:xfrm>
+          <a:prstGeom prst="rect">
+            <a:avLst/>
+          </a:prstGeom>
+          <a:noFill/>
+        </p:spPr>
+        <p:txBody>
+          <a:bodyPr wrap="square">
+            <a:spAutoFit/>
+          </a:bodyPr>
+          <a:lstStyle/>
+          <a:p>
+            <a:pPr>
+              <a:lnSpc>
+                <a:spcPct val="150000"/>
+              </a:lnSpc>
+              <a:buNone/>
+            </a:pPr>
+            <a:r>
+              <a:rPr kumimoji="0" lang="en-US" altLang="en-US" sz="1200" b="1" i="0" u="none" strike="noStrike" cap="none" normalizeH="0" baseline="0">
+                <a:ln>
+                  <a:noFill/>
+                </a:ln>
+                <a:solidFill>
+                  <a:srgbClr val="FF0000"/>
+                </a:solidFill>
+                <a:effectLst/>
+                <a:latin typeface="Arial" panose="020B0604020202020204" pitchFamily="34" charset="0"/>
+              </a:rPr>
+              <a:t>Retrieving Data From Session in Laravel</a:t>
+            </a:r>
+            <a:endParaRPr kumimoji="0" lang="az-Latn-AZ" altLang="en-US" sz="1200" b="1" i="0" u="none" strike="noStrike" cap="none" normalizeH="0" baseline="0">
+              <a:ln>
+                <a:noFill/>
+              </a:ln>
+              <a:solidFill>
+                <a:srgbClr val="FF0000"/>
+              </a:solidFill>
+              <a:effectLst/>
+              <a:latin typeface="Arial" panose="020B0604020202020204" pitchFamily="34" charset="0"/>
+            </a:endParaRPr>
+          </a:p>
+          <a:p>
+            <a:pPr>
+              <a:lnSpc>
+                <a:spcPct val="150000"/>
+              </a:lnSpc>
+              <a:buNone/>
+            </a:pPr>
+            <a:endParaRPr kumimoji="0" lang="en-US" altLang="en-US" sz="1200" b="0" i="0" u="none" strike="noStrike" cap="none" normalizeH="0" baseline="0">
+              <a:ln>
+                <a:noFill/>
+              </a:ln>
+              <a:solidFill>
+                <a:schemeClr val="tx1"/>
+              </a:solidFill>
+              <a:effectLst/>
+              <a:latin typeface="Arial" panose="020B0604020202020204" pitchFamily="34" charset="0"/>
+            </a:endParaRPr>
+          </a:p>
+          <a:p>
+            <a:pPr>
+              <a:lnSpc>
+                <a:spcPct val="150000"/>
+              </a:lnSpc>
+              <a:buNone/>
+            </a:pPr>
+            <a:r>
+              <a:rPr kumimoji="0" lang="en-US" altLang="en-US" sz="1200" b="0" i="0" u="none" strike="noStrike" cap="none" normalizeH="0" baseline="0">
+                <a:ln>
+                  <a:noFill/>
+                </a:ln>
+                <a:solidFill>
+                  <a:schemeClr val="tx1"/>
+                </a:solidFill>
+                <a:effectLst/>
+                <a:latin typeface="Arial" panose="020B0604020202020204" pitchFamily="34" charset="0"/>
+              </a:rPr>
+              <a:t>Sessiyadan məlumat oxumaq (</a:t>
+            </a:r>
+            <a:r>
+              <a:rPr kumimoji="0" lang="en-US" altLang="en-US" sz="1200" b="1" i="0" u="none" strike="noStrike" cap="none" normalizeH="0" baseline="0">
+                <a:ln>
+                  <a:noFill/>
+                </a:ln>
+                <a:solidFill>
+                  <a:schemeClr val="tx1"/>
+                </a:solidFill>
+                <a:effectLst/>
+                <a:latin typeface="Arial" panose="020B0604020202020204" pitchFamily="34" charset="0"/>
+              </a:rPr>
+              <a:t>retrieving</a:t>
+            </a:r>
+            <a:r>
+              <a:rPr kumimoji="0" lang="en-US" altLang="en-US" sz="1200" b="0" i="0" u="none" strike="noStrike" cap="none" normalizeH="0" baseline="0">
+                <a:ln>
+                  <a:noFill/>
+                </a:ln>
+                <a:solidFill>
+                  <a:schemeClr val="tx1"/>
+                </a:solidFill>
+                <a:effectLst/>
+                <a:latin typeface="Arial" panose="020B0604020202020204" pitchFamily="34" charset="0"/>
+              </a:rPr>
+              <a:t>) üçün Laravel bir neçə üsul təqdim edir. Ən çox istifadə olunan metodlar:</a:t>
+            </a:r>
+          </a:p>
+          <a:p>
+            <a:pPr marL="742950" lvl="1" indent="-285750">
+              <a:lnSpc>
+                <a:spcPct val="200000"/>
+              </a:lnSpc>
+              <a:buFont typeface="Arial" panose="020B0604020202020204" pitchFamily="34" charset="0"/>
+              <a:buChar char="•"/>
+            </a:pPr>
+            <a:r>
+              <a:rPr kumimoji="0" lang="en-US" altLang="en-US" sz="1200" b="0" i="0" u="none" strike="noStrike" cap="none" normalizeH="0" baseline="0">
+                <a:ln>
+                  <a:noFill/>
+                </a:ln>
+                <a:solidFill>
+                  <a:schemeClr val="tx1"/>
+                </a:solidFill>
+                <a:effectLst/>
+                <a:latin typeface="Arial" panose="020B0604020202020204" pitchFamily="34" charset="0"/>
+              </a:rPr>
+              <a:t>session()-&gt;get('key')</a:t>
+            </a:r>
+          </a:p>
+          <a:p>
+            <a:pPr marL="742950" lvl="1" indent="-285750">
+              <a:lnSpc>
+                <a:spcPct val="200000"/>
+              </a:lnSpc>
+              <a:buFont typeface="Arial" panose="020B0604020202020204" pitchFamily="34" charset="0"/>
+              <a:buChar char="•"/>
+            </a:pPr>
+            <a:r>
+              <a:rPr kumimoji="0" lang="en-US" altLang="en-US" sz="1200" b="0" i="0" u="none" strike="noStrike" cap="none" normalizeH="0" baseline="0">
+                <a:ln>
+                  <a:noFill/>
+                </a:ln>
+                <a:solidFill>
+                  <a:schemeClr val="tx1"/>
+                </a:solidFill>
+                <a:effectLst/>
+                <a:latin typeface="Arial" panose="020B0604020202020204" pitchFamily="34" charset="0"/>
+              </a:rPr>
+              <a:t>$request-&gt;session()-&gt;get('key')</a:t>
+            </a:r>
+          </a:p>
+          <a:p>
+            <a:pPr marL="742950" lvl="1" indent="-285750">
+              <a:lnSpc>
+                <a:spcPct val="200000"/>
+              </a:lnSpc>
+              <a:buFont typeface="Arial" panose="020B0604020202020204" pitchFamily="34" charset="0"/>
+              <a:buChar char="•"/>
+            </a:pPr>
+            <a:r>
+              <a:rPr kumimoji="0" lang="en-US" altLang="en-US" sz="1200" b="0" i="0" u="none" strike="noStrike" cap="none" normalizeH="0" baseline="0">
+                <a:ln>
+                  <a:noFill/>
+                </a:ln>
+                <a:solidFill>
+                  <a:schemeClr val="tx1"/>
+                </a:solidFill>
+                <a:effectLst/>
+                <a:latin typeface="Arial" panose="020B0604020202020204" pitchFamily="34" charset="0"/>
+              </a:rPr>
+              <a:t>session()-&gt;all() — bütün sessiya məlumatlarını qaytarır.</a:t>
+            </a:r>
+            <a:endParaRPr kumimoji="0" lang="az-Latn-AZ" altLang="en-US" sz="1200" b="0" i="0" u="none" strike="noStrike" cap="none" normalizeH="0" baseline="0">
+              <a:ln>
+                <a:noFill/>
+              </a:ln>
+              <a:solidFill>
+                <a:schemeClr val="tx1"/>
+              </a:solidFill>
+              <a:effectLst/>
+              <a:latin typeface="Arial" panose="020B0604020202020204" pitchFamily="34" charset="0"/>
+            </a:endParaRPr>
+          </a:p>
+          <a:p>
+            <a:pPr>
+              <a:lnSpc>
+                <a:spcPct val="150000"/>
+              </a:lnSpc>
+              <a:buNone/>
+            </a:pPr>
+            <a:endParaRPr kumimoji="0" lang="az-Latn-AZ" altLang="en-US" sz="1200" b="0" i="0" u="none" strike="noStrike" cap="none" normalizeH="0" baseline="0">
+              <a:ln>
+                <a:noFill/>
+              </a:ln>
+              <a:solidFill>
+                <a:schemeClr val="tx1"/>
+              </a:solidFill>
+              <a:effectLst/>
+              <a:latin typeface="Arial" panose="020B0604020202020204" pitchFamily="34" charset="0"/>
+            </a:endParaRPr>
+          </a:p>
+          <a:p>
+            <a:pPr>
+              <a:lnSpc>
+                <a:spcPct val="150000"/>
+              </a:lnSpc>
+              <a:buNone/>
+            </a:pPr>
+            <a:endParaRPr kumimoji="0" lang="az-Latn-AZ" altLang="en-US" sz="1200" b="0" i="0" u="none" strike="noStrike" cap="none" normalizeH="0" baseline="0">
+              <a:ln>
+                <a:noFill/>
+              </a:ln>
+              <a:solidFill>
+                <a:schemeClr val="tx1"/>
+              </a:solidFill>
+              <a:effectLst/>
+              <a:latin typeface="Arial" panose="020B0604020202020204" pitchFamily="34" charset="0"/>
+            </a:endParaRPr>
+          </a:p>
+          <a:p>
+            <a:pPr>
+              <a:lnSpc>
+                <a:spcPct val="150000"/>
+              </a:lnSpc>
+              <a:buNone/>
+            </a:pPr>
+            <a:r>
+              <a:rPr kumimoji="0" lang="en-US" altLang="en-US" sz="1200" b="1" i="0" u="none" strike="noStrike" cap="none" normalizeH="0" baseline="0">
+                <a:ln>
+                  <a:noFill/>
+                </a:ln>
+                <a:solidFill>
+                  <a:schemeClr val="tx1"/>
+                </a:solidFill>
+                <a:effectLst/>
+                <a:latin typeface="Arial" panose="020B0604020202020204" pitchFamily="34" charset="0"/>
+              </a:rPr>
+              <a:t>İzah</a:t>
+            </a:r>
+            <a:r>
+              <a:rPr kumimoji="0" lang="en-US" altLang="en-US" sz="1200" b="0" i="0" u="none" strike="noStrike" cap="none" normalizeH="0" baseline="0">
+                <a:ln>
+                  <a:noFill/>
+                </a:ln>
+                <a:solidFill>
+                  <a:schemeClr val="tx1"/>
+                </a:solidFill>
+                <a:effectLst/>
+                <a:latin typeface="Arial" panose="020B0604020202020204" pitchFamily="34" charset="0"/>
+              </a:rPr>
+              <a:t>:</a:t>
+            </a:r>
+          </a:p>
+          <a:p>
+            <a:pPr marL="171450" indent="-171450">
+              <a:lnSpc>
+                <a:spcPct val="150000"/>
+              </a:lnSpc>
+              <a:buFont typeface="Arial" panose="020B0604020202020204" pitchFamily="34" charset="0"/>
+              <a:buChar char="•"/>
+            </a:pPr>
+            <a:r>
+              <a:rPr kumimoji="0" lang="en-US" altLang="en-US" sz="1200" b="0" i="0" u="none" strike="noStrike" cap="none" normalizeH="0" baseline="0">
+                <a:ln>
+                  <a:noFill/>
+                </a:ln>
+                <a:solidFill>
+                  <a:schemeClr val="tx1"/>
+                </a:solidFill>
+                <a:effectLst/>
+                <a:latin typeface="Arial" panose="020B0604020202020204" pitchFamily="34" charset="0"/>
+              </a:rPr>
+              <a:t>Bu nümunədə </a:t>
+            </a:r>
+            <a:r>
+              <a:rPr kumimoji="0" lang="en-US" altLang="en-US" sz="1200" b="1" i="0" u="none" strike="noStrike" cap="none" normalizeH="0" baseline="0">
+                <a:ln>
+                  <a:noFill/>
+                </a:ln>
+                <a:solidFill>
+                  <a:schemeClr val="tx1"/>
+                </a:solidFill>
+                <a:effectLst/>
+                <a:latin typeface="Arial" panose="020B0604020202020204" pitchFamily="34" charset="0"/>
+              </a:rPr>
+              <a:t>session() </a:t>
+            </a:r>
+            <a:r>
+              <a:rPr kumimoji="0" lang="en-US" altLang="en-US" sz="1200" b="0" i="0" u="none" strike="noStrike" cap="none" normalizeH="0" baseline="0">
+                <a:ln>
+                  <a:noFill/>
+                </a:ln>
+                <a:solidFill>
+                  <a:schemeClr val="tx1"/>
+                </a:solidFill>
+                <a:effectLst/>
+                <a:latin typeface="Arial" panose="020B0604020202020204" pitchFamily="34" charset="0"/>
+              </a:rPr>
+              <a:t>helper funksiyası qlobal şəkildə çağırılır.</a:t>
+            </a:r>
+          </a:p>
+          <a:p>
+            <a:pPr marL="171450" indent="-171450">
+              <a:lnSpc>
+                <a:spcPct val="150000"/>
+              </a:lnSpc>
+              <a:buFont typeface="Arial" panose="020B0604020202020204" pitchFamily="34" charset="0"/>
+              <a:buChar char="•"/>
+            </a:pPr>
+            <a:r>
+              <a:rPr kumimoji="0" lang="en-US" altLang="en-US" sz="1200" b="1" i="0" u="none" strike="noStrike" cap="none" normalizeH="0" baseline="0">
+                <a:ln>
+                  <a:noFill/>
+                </a:ln>
+                <a:solidFill>
+                  <a:schemeClr val="tx1"/>
+                </a:solidFill>
+                <a:effectLst/>
+                <a:latin typeface="Arial" panose="020B0604020202020204" pitchFamily="34" charset="0"/>
+              </a:rPr>
+              <a:t>session()-&gt;all() </a:t>
+            </a:r>
+            <a:r>
+              <a:rPr kumimoji="0" lang="en-US" altLang="en-US" sz="1200" b="0" i="0" u="none" strike="noStrike" cap="none" normalizeH="0" baseline="0">
+                <a:ln>
+                  <a:noFill/>
+                </a:ln>
+                <a:solidFill>
+                  <a:schemeClr val="tx1"/>
+                </a:solidFill>
+                <a:effectLst/>
+                <a:latin typeface="Arial" panose="020B0604020202020204" pitchFamily="34" charset="0"/>
+              </a:rPr>
+              <a:t>vasitəsilə bütün sessiya məlumatları alınır.</a:t>
+            </a:r>
+          </a:p>
+          <a:p>
+            <a:pPr marL="171450" indent="-171450">
+              <a:lnSpc>
+                <a:spcPct val="150000"/>
+              </a:lnSpc>
+              <a:buFont typeface="Arial" panose="020B0604020202020204" pitchFamily="34" charset="0"/>
+              <a:buChar char="•"/>
+            </a:pPr>
+            <a:r>
+              <a:rPr kumimoji="0" lang="en-US" altLang="en-US" sz="1200" b="1" i="0" u="none" strike="noStrike" cap="none" normalizeH="0" baseline="0">
+                <a:ln>
+                  <a:noFill/>
+                </a:ln>
+                <a:solidFill>
+                  <a:schemeClr val="tx1"/>
+                </a:solidFill>
+                <a:effectLst/>
+                <a:latin typeface="Arial" panose="020B0604020202020204" pitchFamily="34" charset="0"/>
+              </a:rPr>
+              <a:t>dd($data) </a:t>
+            </a:r>
+            <a:r>
+              <a:rPr kumimoji="0" lang="en-US" altLang="en-US" sz="1200" b="0" i="0" u="none" strike="noStrike" cap="none" normalizeH="0" baseline="0">
+                <a:ln>
+                  <a:noFill/>
+                </a:ln>
+                <a:solidFill>
+                  <a:schemeClr val="tx1"/>
+                </a:solidFill>
+                <a:effectLst/>
+                <a:latin typeface="Arial" panose="020B0604020202020204" pitchFamily="34" charset="0"/>
+              </a:rPr>
+              <a:t>vasitəsilə brauzerdə göstərilir.</a:t>
+            </a:r>
+          </a:p>
+          <a:p>
+            <a:pPr>
+              <a:lnSpc>
+                <a:spcPct val="150000"/>
+              </a:lnSpc>
+              <a:buNone/>
+            </a:pPr>
+            <a:endParaRPr kumimoji="0" lang="az-Latn-AZ" altLang="en-US" sz="1200" b="0" i="0" u="none" strike="noStrike" cap="none" normalizeH="0" baseline="0">
+              <a:ln>
+                <a:noFill/>
+              </a:ln>
+              <a:solidFill>
+                <a:schemeClr val="tx1"/>
+              </a:solidFill>
+              <a:effectLst/>
+              <a:latin typeface="Arial" panose="020B0604020202020204" pitchFamily="34" charset="0"/>
+            </a:endParaRPr>
+          </a:p>
+          <a:p>
+            <a:pPr>
+              <a:lnSpc>
+                <a:spcPct val="150000"/>
+              </a:lnSpc>
+              <a:buNone/>
+            </a:pPr>
+            <a:endParaRPr kumimoji="0" lang="az-Latn-AZ" altLang="en-US" sz="1200" b="0" i="0" u="none" strike="noStrike" cap="none" normalizeH="0" baseline="0">
+              <a:ln>
+                <a:noFill/>
+              </a:ln>
+              <a:solidFill>
+                <a:schemeClr val="tx1"/>
+              </a:solidFill>
+              <a:effectLst/>
+              <a:latin typeface="Arial" panose="020B0604020202020204" pitchFamily="34" charset="0"/>
+            </a:endParaRPr>
+          </a:p>
+          <a:p>
+            <a:pPr>
+              <a:lnSpc>
+                <a:spcPct val="150000"/>
+              </a:lnSpc>
+              <a:buNone/>
+            </a:pPr>
+            <a:endParaRPr lang="az-Latn-AZ" altLang="en-US" sz="1200">
+              <a:latin typeface="Arial" panose="020B0604020202020204" pitchFamily="34" charset="0"/>
+            </a:endParaRPr>
+          </a:p>
+          <a:p>
+            <a:pPr>
+              <a:lnSpc>
+                <a:spcPct val="150000"/>
+              </a:lnSpc>
+              <a:buNone/>
+            </a:pPr>
+            <a:endParaRPr kumimoji="0" lang="en-US" altLang="en-US" sz="1200" b="0" i="0" u="none" strike="noStrike" cap="none" normalizeH="0" baseline="0">
+              <a:ln>
+                <a:noFill/>
+              </a:ln>
+              <a:solidFill>
+                <a:schemeClr val="tx1"/>
+              </a:solidFill>
+              <a:effectLst/>
+              <a:latin typeface="Arial" panose="020B0604020202020204" pitchFamily="34" charset="0"/>
+            </a:endParaRPr>
+          </a:p>
+          <a:p>
+            <a:pPr>
+              <a:lnSpc>
+                <a:spcPct val="150000"/>
+              </a:lnSpc>
+              <a:buNone/>
+            </a:pPr>
+            <a:r>
+              <a:rPr kumimoji="0" lang="en-US" altLang="en-US" sz="1200" b="1" i="0" u="none" strike="noStrike" cap="none" normalizeH="0" baseline="0">
+                <a:ln>
+                  <a:noFill/>
+                </a:ln>
+                <a:solidFill>
+                  <a:schemeClr val="tx1"/>
+                </a:solidFill>
+                <a:effectLst/>
+                <a:latin typeface="Arial" panose="020B0604020202020204" pitchFamily="34" charset="0"/>
+              </a:rPr>
+              <a:t>Qeyd</a:t>
+            </a:r>
+            <a:r>
+              <a:rPr kumimoji="0" lang="en-US" altLang="en-US" sz="1200" b="0" i="0" u="none" strike="noStrike" cap="none" normalizeH="0" baseline="0">
+                <a:ln>
+                  <a:noFill/>
+                </a:ln>
+                <a:solidFill>
+                  <a:schemeClr val="tx1"/>
+                </a:solidFill>
+                <a:effectLst/>
+                <a:latin typeface="Arial" panose="020B0604020202020204" pitchFamily="34" charset="0"/>
+              </a:rPr>
+              <a:t>:</a:t>
+            </a:r>
+          </a:p>
+          <a:p>
+            <a:pPr marL="171450" indent="-171450">
+              <a:lnSpc>
+                <a:spcPct val="150000"/>
+              </a:lnSpc>
+              <a:buFont typeface="Arial" panose="020B0604020202020204" pitchFamily="34" charset="0"/>
+              <a:buChar char="•"/>
+            </a:pPr>
+            <a:r>
+              <a:rPr kumimoji="0" lang="en-US" altLang="en-US" sz="1200" b="1" i="0" u="none" strike="noStrike" cap="none" normalizeH="0" baseline="0">
+                <a:ln>
+                  <a:noFill/>
+                </a:ln>
+                <a:solidFill>
+                  <a:schemeClr val="tx1"/>
+                </a:solidFill>
+                <a:effectLst/>
+                <a:latin typeface="Arial" panose="020B0604020202020204" pitchFamily="34" charset="0"/>
+              </a:rPr>
+              <a:t>Request</a:t>
+            </a:r>
+            <a:r>
+              <a:rPr kumimoji="0" lang="en-US" altLang="en-US" sz="1200" b="0" i="0" u="none" strike="noStrike" cap="none" normalizeH="0" baseline="0">
+                <a:ln>
+                  <a:noFill/>
+                </a:ln>
+                <a:solidFill>
+                  <a:schemeClr val="tx1"/>
+                </a:solidFill>
+                <a:effectLst/>
+                <a:latin typeface="Arial" panose="020B0604020202020204" pitchFamily="34" charset="0"/>
+              </a:rPr>
+              <a:t> obyektinə ehtiyac yoxdur.</a:t>
+            </a:r>
+          </a:p>
+          <a:p>
+            <a:pPr marL="171450" indent="-171450">
+              <a:lnSpc>
+                <a:spcPct val="150000"/>
+              </a:lnSpc>
+              <a:buFont typeface="Arial" panose="020B0604020202020204" pitchFamily="34" charset="0"/>
+              <a:buChar char="•"/>
+            </a:pPr>
+            <a:r>
+              <a:rPr kumimoji="0" lang="en-US" altLang="en-US" sz="1200" b="0" i="0" u="none" strike="noStrike" cap="none" normalizeH="0" baseline="0">
+                <a:ln>
+                  <a:noFill/>
+                </a:ln>
+                <a:solidFill>
+                  <a:schemeClr val="tx1"/>
+                </a:solidFill>
+                <a:effectLst/>
+                <a:latin typeface="Arial" panose="020B0604020202020204" pitchFamily="34" charset="0"/>
+              </a:rPr>
+              <a:t>Əgər route funksiyasında </a:t>
+            </a:r>
+            <a:r>
+              <a:rPr kumimoji="0" lang="en-US" altLang="en-US" sz="1200" b="1" i="0" u="none" strike="noStrike" cap="none" normalizeH="0" baseline="0">
+                <a:ln>
+                  <a:noFill/>
+                </a:ln>
+                <a:solidFill>
+                  <a:schemeClr val="tx1"/>
+                </a:solidFill>
+                <a:effectLst/>
+                <a:latin typeface="Arial" panose="020B0604020202020204" pitchFamily="34" charset="0"/>
+              </a:rPr>
+              <a:t>Request</a:t>
+            </a:r>
+            <a:r>
+              <a:rPr kumimoji="0" lang="en-US" altLang="en-US" sz="1200" b="0" i="0" u="none" strike="noStrike" cap="none" normalizeH="0" baseline="0">
+                <a:ln>
+                  <a:noFill/>
+                </a:ln>
+                <a:solidFill>
+                  <a:schemeClr val="tx1"/>
+                </a:solidFill>
+                <a:effectLst/>
+                <a:latin typeface="Arial" panose="020B0604020202020204" pitchFamily="34" charset="0"/>
+              </a:rPr>
+              <a:t> istifadə olunmayacaqsa, bu üsul daha qısadır və </a:t>
+            </a:r>
+            <a:br>
+              <a:rPr lang="az-Latn-AZ" altLang="en-US" sz="1200">
+                <a:latin typeface="Arial" panose="020B0604020202020204" pitchFamily="34" charset="0"/>
+              </a:rPr>
+            </a:br>
+            <a:r>
+              <a:rPr kumimoji="0" lang="en-US" altLang="en-US" sz="1200" b="0" i="0" u="none" strike="noStrike" cap="none" normalizeH="0" baseline="0">
+                <a:ln>
+                  <a:noFill/>
+                </a:ln>
+                <a:solidFill>
+                  <a:schemeClr val="tx1"/>
+                </a:solidFill>
+                <a:effectLst/>
+                <a:latin typeface="Arial" panose="020B0604020202020204" pitchFamily="34" charset="0"/>
+              </a:rPr>
+              <a:t>rahatdır.</a:t>
+            </a:r>
+          </a:p>
+        </p:txBody>
+      </p:sp>
+      <p:pic>
+        <p:nvPicPr>
+          <p:cNvPr id="8" name="Picture 7">
+            <a:extLst>
+              <a:ext uri="{FF2B5EF4-FFF2-40B4-BE49-F238E27FC236}">
+                <a16:creationId xmlns:a16="http://schemas.microsoft.com/office/drawing/2014/main" id="{81461923-42CE-7EB8-A7D8-EBA80DE0C0DC}"/>
+              </a:ext>
+            </a:extLst>
+          </p:cNvPr>
+          <p:cNvPicPr>
+            <a:picLocks noChangeAspect="1"/>
+          </p:cNvPicPr>
+          <p:nvPr/>
+        </p:nvPicPr>
+        <p:blipFill>
+          <a:blip r:embed="rId2"/>
+          <a:stretch>
+            <a:fillRect/>
+          </a:stretch>
+        </p:blipFill>
+        <p:spPr>
+          <a:xfrm>
+            <a:off x="6407648" y="3346515"/>
+            <a:ext cx="5784351" cy="3511485"/>
+          </a:xfrm>
+          <a:prstGeom prst="rect">
+            <a:avLst/>
+          </a:prstGeom>
+        </p:spPr>
+      </p:pic>
+      <p:pic>
+        <p:nvPicPr>
+          <p:cNvPr id="10" name="Picture 9">
+            <a:extLst>
+              <a:ext uri="{FF2B5EF4-FFF2-40B4-BE49-F238E27FC236}">
+                <a16:creationId xmlns:a16="http://schemas.microsoft.com/office/drawing/2014/main" id="{6B2DCEC6-4913-AC16-DCBC-33E9D48E959D}"/>
+              </a:ext>
+            </a:extLst>
+          </p:cNvPr>
+          <p:cNvPicPr>
+            <a:picLocks noChangeAspect="1"/>
+          </p:cNvPicPr>
+          <p:nvPr/>
+        </p:nvPicPr>
+        <p:blipFill>
+          <a:blip r:embed="rId3"/>
+          <a:stretch>
+            <a:fillRect/>
+          </a:stretch>
+        </p:blipFill>
+        <p:spPr>
+          <a:xfrm>
+            <a:off x="8993170" y="93476"/>
+            <a:ext cx="3117797" cy="1011524"/>
+          </a:xfrm>
+          <a:prstGeom prst="rect">
+            <a:avLst/>
+          </a:prstGeom>
+          <a:ln w="38100" cap="sq">
+            <a:solidFill>
+              <a:srgbClr val="000000"/>
+            </a:solidFill>
+            <a:prstDash val="solid"/>
+            <a:miter lim="800000"/>
+          </a:ln>
+          <a:effectLst>
+            <a:outerShdw blurRad="50800" dist="38100" dir="2700000" algn="tl" rotWithShape="0">
+              <a:srgbClr val="000000">
+                <a:alpha val="43000"/>
+              </a:srgbClr>
+            </a:outerShdw>
+          </a:effectLst>
+        </p:spPr>
+      </p:pic>
+    </p:spTree>
+    <p:extLst>
+      <p:ext uri="{BB962C8B-B14F-4D97-AF65-F5344CB8AC3E}">
+        <p14:creationId xmlns:p14="http://schemas.microsoft.com/office/powerpoint/2010/main" val="2486611332"/>
+      </p:ext>
+    </p:extLst>
+  </p:cSld>
+  <p:clrMapOvr>
+    <a:masterClrMapping/>
+  </p:clrMapOvr>
+</p:sld>
+</file>
+
+<file path=ppt/slides/slide10.xml><?xml version="1.0" encoding="utf-8"?>
+<p:sld xmlns:a="http://schemas.openxmlformats.org/drawingml/2006/main" xmlns:r="http://schemas.openxmlformats.org/officeDocument/2006/relationships" xmlns:p="http://schemas.openxmlformats.org/presentationml/2006/main">
+  <p:cSld>
+    <p:spTree>
+      <p:nvGrpSpPr>
+        <p:cNvPr id="1" name="">
+          <a:extLst>
+            <a:ext uri="{FF2B5EF4-FFF2-40B4-BE49-F238E27FC236}">
+              <a16:creationId xmlns:a16="http://schemas.microsoft.com/office/drawing/2014/main" id="{524FE7CE-A35B-E68B-D99C-496BBD2E2657}"/>
+            </a:ext>
+          </a:extLst>
+        </p:cNvPr>
+        <p:cNvGrpSpPr/>
+        <p:nvPr/>
+      </p:nvGrpSpPr>
+      <p:grpSpPr>
+        <a:xfrm>
+          <a:off x="0" y="0"/>
+          <a:ext cx="0" cy="0"/>
+          <a:chOff x="0" y="0"/>
+          <a:chExt cx="0" cy="0"/>
+        </a:xfrm>
+      </p:grpSpPr>
+      <p:sp>
+        <p:nvSpPr>
+          <p:cNvPr id="3" name="TextBox 2">
+            <a:extLst>
+              <a:ext uri="{FF2B5EF4-FFF2-40B4-BE49-F238E27FC236}">
+                <a16:creationId xmlns:a16="http://schemas.microsoft.com/office/drawing/2014/main" id="{034880DB-280A-D264-A699-5C5863FE01B9}"/>
+              </a:ext>
+            </a:extLst>
+          </p:cNvPr>
+          <p:cNvSpPr txBox="1"/>
+          <p:nvPr/>
+        </p:nvSpPr>
+        <p:spPr>
+          <a:xfrm>
+            <a:off x="217714" y="255046"/>
             <a:ext cx="11756571" cy="355354"/>
           </a:xfrm>
           <a:prstGeom prst="rect">
@@ -3387,7 +4093,7 @@
     </p:spTree>
     <p:extLst>
       <p:ext uri="{BB962C8B-B14F-4D97-AF65-F5344CB8AC3E}">
-        <p14:creationId xmlns:p14="http://schemas.microsoft.com/office/powerpoint/2010/main" val="2486611332"/>
+        <p14:creationId xmlns:p14="http://schemas.microsoft.com/office/powerpoint/2010/main" val="2611768441"/>
       </p:ext>
     </p:extLst>
   </p:cSld>
@@ -3420,12 +4126,86 @@
           <a:chExt cx="0" cy="0"/>
         </a:xfrm>
       </p:grpSpPr>
+      <p:pic>
+        <p:nvPicPr>
+          <p:cNvPr id="4" name="Picture 3">
+            <a:extLst>
+              <a:ext uri="{FF2B5EF4-FFF2-40B4-BE49-F238E27FC236}">
+                <a16:creationId xmlns:a16="http://schemas.microsoft.com/office/drawing/2014/main" id="{05125254-C28E-5304-4BC7-01DE2F3D54C7}"/>
+              </a:ext>
+            </a:extLst>
+          </p:cNvPr>
+          <p:cNvPicPr>
+            <a:picLocks noChangeAspect="1"/>
+          </p:cNvPicPr>
+          <p:nvPr/>
+        </p:nvPicPr>
+        <p:blipFill>
+          <a:blip r:embed="rId2"/>
+          <a:stretch>
+            <a:fillRect/>
+          </a:stretch>
+        </p:blipFill>
+        <p:spPr>
+          <a:xfrm>
+            <a:off x="4843587" y="0"/>
+            <a:ext cx="7348413" cy="6858000"/>
+          </a:xfrm>
+          <a:prstGeom prst="rect">
+            <a:avLst/>
+          </a:prstGeom>
+        </p:spPr>
+      </p:pic>
+      <p:pic>
+        <p:nvPicPr>
+          <p:cNvPr id="6" name="Picture 5">
+            <a:extLst>
+              <a:ext uri="{FF2B5EF4-FFF2-40B4-BE49-F238E27FC236}">
+                <a16:creationId xmlns:a16="http://schemas.microsoft.com/office/drawing/2014/main" id="{866D5B99-8D4D-A2AC-D283-9E7EF3653356}"/>
+              </a:ext>
+            </a:extLst>
+          </p:cNvPr>
+          <p:cNvPicPr>
+            <a:picLocks noChangeAspect="1"/>
+          </p:cNvPicPr>
+          <p:nvPr/>
+        </p:nvPicPr>
+        <p:blipFill>
+          <a:blip r:embed="rId3"/>
+          <a:stretch>
+            <a:fillRect/>
+          </a:stretch>
+        </p:blipFill>
+        <p:spPr>
+          <a:xfrm>
+            <a:off x="90558" y="5230192"/>
+            <a:ext cx="4620270" cy="1514686"/>
+          </a:xfrm>
+          <a:prstGeom prst="rect">
+            <a:avLst/>
+          </a:prstGeom>
+          <a:ln w="38100" cap="sq">
+            <a:solidFill>
+              <a:srgbClr val="000000"/>
+            </a:solidFill>
+            <a:prstDash val="solid"/>
+            <a:miter lim="800000"/>
+          </a:ln>
+          <a:effectLst>
+            <a:outerShdw blurRad="50800" dist="38100" dir="2700000" algn="tl" rotWithShape="0">
+              <a:srgbClr val="000000">
+                <a:alpha val="43000"/>
+              </a:srgbClr>
+            </a:outerShdw>
+          </a:effectLst>
+        </p:spPr>
+      </p:pic>
       <p:sp>
         <p:nvSpPr>
-          <p:cNvPr id="3" name="TextBox 2">
-            <a:extLst>
-              <a:ext uri="{FF2B5EF4-FFF2-40B4-BE49-F238E27FC236}">
-                <a16:creationId xmlns:a16="http://schemas.microsoft.com/office/drawing/2014/main" id="{81782941-0DB4-B0DA-A36A-31CA5EC69992}"/>
+          <p:cNvPr id="8" name="TextBox 7">
+            <a:extLst>
+              <a:ext uri="{FF2B5EF4-FFF2-40B4-BE49-F238E27FC236}">
+                <a16:creationId xmlns:a16="http://schemas.microsoft.com/office/drawing/2014/main" id="{B640A485-663D-8316-4CCF-30D651FE4EFC}"/>
               </a:ext>
             </a:extLst>
           </p:cNvPr>
@@ -3434,8 +4214,8 @@
         </p:nvSpPr>
         <p:spPr>
           <a:xfrm>
-            <a:off x="217714" y="255046"/>
-            <a:ext cx="11756571" cy="355354"/>
+            <a:off x="200320" y="391114"/>
+            <a:ext cx="4510508" cy="4524315"/>
           </a:xfrm>
           <a:prstGeom prst="rect">
             <a:avLst/>
@@ -3448,24 +4228,127 @@
           </a:bodyPr>
           <a:lstStyle/>
           <a:p>
-            <a:pPr>
-              <a:lnSpc>
-                <a:spcPct val="150000"/>
-              </a:lnSpc>
-              <a:buNone/>
+            <a:pPr marL="285750" indent="-285750">
+              <a:buFont typeface="Arial" panose="020B0604020202020204" pitchFamily="34" charset="0"/>
+              <a:buChar char="•"/>
             </a:pPr>
             <a:r>
-              <a:rPr kumimoji="0" lang="en-US" altLang="en-US" sz="1300" b="0" i="0" u="none" strike="noStrike" cap="none" normalizeH="0" baseline="0">
-                <a:ln>
-                  <a:noFill/>
-                </a:ln>
-                <a:solidFill>
-                  <a:schemeClr val="tx1"/>
-                </a:solidFill>
-                <a:effectLst/>
-                <a:latin typeface="Arial" panose="020B0604020202020204" pitchFamily="34" charset="0"/>
-              </a:rPr>
-              <a:t>.</a:t>
+              <a:rPr lang="en-US" sz="1600"/>
+              <a:t>Burada isə sessiyaya </a:t>
+            </a:r>
+            <a:r>
+              <a:rPr lang="en-US" sz="1600" b="1"/>
+              <a:t>HTTP</a:t>
+            </a:r>
+            <a:r>
+              <a:rPr lang="en-US" sz="1600"/>
+              <a:t> sorğusu (</a:t>
+            </a:r>
+            <a:r>
+              <a:rPr lang="en-US" sz="1600" b="1"/>
+              <a:t>Request</a:t>
+            </a:r>
+            <a:r>
+              <a:rPr lang="en-US" sz="1600"/>
+              <a:t>) obyektindən daxil olunur.</a:t>
+            </a:r>
+            <a:endParaRPr lang="az-Latn-AZ" sz="1600"/>
+          </a:p>
+          <a:p>
+            <a:endParaRPr lang="az-Latn-AZ" sz="1600"/>
+          </a:p>
+          <a:p>
+            <a:endParaRPr lang="en-US" sz="1600"/>
+          </a:p>
+          <a:p>
+            <a:endParaRPr lang="en-US" sz="1600"/>
+          </a:p>
+          <a:p>
+            <a:pPr marL="285750" indent="-285750">
+              <a:buFont typeface="Arial" panose="020B0604020202020204" pitchFamily="34" charset="0"/>
+              <a:buChar char="•"/>
+            </a:pPr>
+            <a:r>
+              <a:rPr lang="en-US" sz="1600" b="1"/>
+              <a:t>$request-&gt;session() </a:t>
+            </a:r>
+            <a:r>
+              <a:rPr lang="en-US" sz="1600"/>
+              <a:t>metodu Laravel-in dependency injection sistemindən istifadə edir.</a:t>
+            </a:r>
+          </a:p>
+          <a:p>
+            <a:endParaRPr lang="az-Latn-AZ" sz="1600"/>
+          </a:p>
+          <a:p>
+            <a:endParaRPr lang="az-Latn-AZ" sz="1600"/>
+          </a:p>
+          <a:p>
+            <a:endParaRPr lang="en-US" sz="1600"/>
+          </a:p>
+          <a:p>
+            <a:pPr marL="285750" indent="-285750">
+              <a:buFont typeface="Arial" panose="020B0604020202020204" pitchFamily="34" charset="0"/>
+              <a:buChar char="•"/>
+            </a:pPr>
+            <a:r>
+              <a:rPr lang="en-US" sz="1600"/>
+              <a:t>Bu üsul əsasən </a:t>
+            </a:r>
+            <a:r>
+              <a:rPr lang="en-US" sz="1600" b="1"/>
+              <a:t>middleware</a:t>
+            </a:r>
+            <a:r>
+              <a:rPr lang="en-US" sz="1600"/>
+              <a:t> və ya </a:t>
+            </a:r>
+            <a:r>
+              <a:rPr lang="en-US" sz="1600" b="1"/>
+              <a:t>request</a:t>
+            </a:r>
+            <a:r>
+              <a:rPr lang="en-US" sz="1600"/>
+              <a:t> əsaslı manipulyasiyalar üçün daha uyğundur.</a:t>
+            </a:r>
+          </a:p>
+          <a:p>
+            <a:endParaRPr lang="az-Latn-AZ" sz="1600"/>
+          </a:p>
+          <a:p>
+            <a:endParaRPr lang="az-Latn-AZ" sz="1600"/>
+          </a:p>
+          <a:p>
+            <a:endParaRPr lang="en-US" sz="1600"/>
+          </a:p>
+          <a:p>
+            <a:pPr marL="285750" indent="-285750">
+              <a:buFont typeface="Arial" panose="020B0604020202020204" pitchFamily="34" charset="0"/>
+              <a:buChar char="•"/>
+            </a:pPr>
+            <a:r>
+              <a:rPr lang="az-Latn-AZ" sz="1600"/>
+              <a:t>Yəni, f</a:t>
+            </a:r>
+            <a:r>
+              <a:rPr lang="en-US" sz="1600"/>
+              <a:t>unksiyanın içində </a:t>
+            </a:r>
+            <a:r>
+              <a:rPr lang="en-US" sz="1600" b="1"/>
+              <a:t>həm</a:t>
+            </a:r>
+            <a:r>
+              <a:rPr lang="en-US" sz="1600"/>
+              <a:t> sessiya, </a:t>
+            </a:r>
+            <a:r>
+              <a:rPr lang="en-US" sz="1600" b="1"/>
+              <a:t>həm də </a:t>
+            </a:r>
+            <a:r>
+              <a:rPr lang="en-US" sz="1600"/>
+              <a:t>digər sorğu məlumatları istifadə olunacaqsa, bu üsul daha məntiqlidir.</a:t>
             </a:r>
           </a:p>
         </p:txBody>
@@ -3521,6 +4404,393 @@
         <p:spPr>
           <a:xfrm>
             <a:off x="217714" y="255046"/>
+            <a:ext cx="4629797" cy="3356175"/>
+          </a:xfrm>
+          <a:prstGeom prst="rect">
+            <a:avLst/>
+          </a:prstGeom>
+          <a:noFill/>
+        </p:spPr>
+        <p:txBody>
+          <a:bodyPr wrap="square">
+            <a:spAutoFit/>
+          </a:bodyPr>
+          <a:lstStyle/>
+          <a:p>
+            <a:pPr>
+              <a:lnSpc>
+                <a:spcPct val="150000"/>
+              </a:lnSpc>
+              <a:buNone/>
+            </a:pPr>
+            <a:r>
+              <a:rPr kumimoji="0" lang="en-US" altLang="en-US" sz="1300" b="0" i="0" u="none" strike="noStrike" cap="none" normalizeH="0" baseline="0">
+                <a:ln>
+                  <a:noFill/>
+                </a:ln>
+                <a:solidFill>
+                  <a:schemeClr val="tx1"/>
+                </a:solidFill>
+                <a:effectLst/>
+                <a:latin typeface="Arial" panose="020B0604020202020204" pitchFamily="34" charset="0"/>
+              </a:rPr>
+              <a:t>Bu nümunədə konkret olaraq </a:t>
+            </a:r>
+            <a:r>
+              <a:rPr kumimoji="0" lang="en-US" altLang="en-US" sz="1300" b="1" i="0" u="none" strike="noStrike" cap="none" normalizeH="0" baseline="0">
+                <a:ln>
+                  <a:noFill/>
+                </a:ln>
+                <a:solidFill>
+                  <a:schemeClr val="tx1"/>
+                </a:solidFill>
+                <a:effectLst/>
+                <a:latin typeface="Arial" panose="020B0604020202020204" pitchFamily="34" charset="0"/>
+              </a:rPr>
+              <a:t>_token </a:t>
+            </a:r>
+            <a:r>
+              <a:rPr kumimoji="0" lang="en-US" altLang="en-US" sz="1300" b="0" i="0" u="none" strike="noStrike" cap="none" normalizeH="0" baseline="0">
+                <a:ln>
+                  <a:noFill/>
+                </a:ln>
+                <a:solidFill>
+                  <a:schemeClr val="tx1"/>
+                </a:solidFill>
+                <a:effectLst/>
+                <a:latin typeface="Arial" panose="020B0604020202020204" pitchFamily="34" charset="0"/>
+              </a:rPr>
+              <a:t>adlı tək bir sessiya məlumatı əldə edilir.</a:t>
+            </a:r>
+          </a:p>
+          <a:p>
+            <a:pPr>
+              <a:lnSpc>
+                <a:spcPct val="150000"/>
+              </a:lnSpc>
+              <a:buNone/>
+            </a:pPr>
+            <a:endParaRPr kumimoji="0" lang="az-Latn-AZ" altLang="en-US" sz="1300" b="0" i="0" u="none" strike="noStrike" cap="none" normalizeH="0" baseline="0">
+              <a:ln>
+                <a:noFill/>
+              </a:ln>
+              <a:solidFill>
+                <a:schemeClr val="tx1"/>
+              </a:solidFill>
+              <a:effectLst/>
+              <a:latin typeface="Arial" panose="020B0604020202020204" pitchFamily="34" charset="0"/>
+            </a:endParaRPr>
+          </a:p>
+          <a:p>
+            <a:pPr>
+              <a:lnSpc>
+                <a:spcPct val="150000"/>
+              </a:lnSpc>
+              <a:buNone/>
+            </a:pPr>
+            <a:endParaRPr lang="az-Latn-AZ" altLang="en-US" sz="1300">
+              <a:latin typeface="Arial" panose="020B0604020202020204" pitchFamily="34" charset="0"/>
+            </a:endParaRPr>
+          </a:p>
+          <a:p>
+            <a:pPr>
+              <a:lnSpc>
+                <a:spcPct val="150000"/>
+              </a:lnSpc>
+              <a:buNone/>
+            </a:pPr>
+            <a:endParaRPr kumimoji="0" lang="en-US" altLang="en-US" sz="1300" b="0" i="0" u="none" strike="noStrike" cap="none" normalizeH="0" baseline="0">
+              <a:ln>
+                <a:noFill/>
+              </a:ln>
+              <a:solidFill>
+                <a:schemeClr val="tx1"/>
+              </a:solidFill>
+              <a:effectLst/>
+              <a:latin typeface="Arial" panose="020B0604020202020204" pitchFamily="34" charset="0"/>
+            </a:endParaRPr>
+          </a:p>
+          <a:p>
+            <a:pPr>
+              <a:lnSpc>
+                <a:spcPct val="150000"/>
+              </a:lnSpc>
+              <a:buNone/>
+            </a:pPr>
+            <a:r>
+              <a:rPr kumimoji="0" lang="en-US" altLang="en-US" sz="1300" b="1" i="0" u="none" strike="noStrike" cap="none" normalizeH="0" baseline="0">
+                <a:ln>
+                  <a:noFill/>
+                </a:ln>
+                <a:solidFill>
+                  <a:schemeClr val="tx1"/>
+                </a:solidFill>
+                <a:effectLst/>
+                <a:latin typeface="Arial" panose="020B0604020202020204" pitchFamily="34" charset="0"/>
+              </a:rPr>
+              <a:t>_token </a:t>
+            </a:r>
+            <a:r>
+              <a:rPr kumimoji="0" lang="en-US" altLang="en-US" sz="1300" b="0" i="0" u="none" strike="noStrike" cap="none" normalizeH="0" baseline="0">
+                <a:ln>
+                  <a:noFill/>
+                </a:ln>
+                <a:solidFill>
+                  <a:schemeClr val="tx1"/>
+                </a:solidFill>
+                <a:effectLst/>
+                <a:latin typeface="Arial" panose="020B0604020202020204" pitchFamily="34" charset="0"/>
+              </a:rPr>
+              <a:t>Laravel-in </a:t>
+            </a:r>
+            <a:r>
+              <a:rPr kumimoji="0" lang="en-US" altLang="en-US" sz="1300" b="1" i="0" u="none" strike="noStrike" cap="none" normalizeH="0" baseline="0">
+                <a:ln>
+                  <a:noFill/>
+                </a:ln>
+                <a:solidFill>
+                  <a:schemeClr val="tx1"/>
+                </a:solidFill>
+                <a:effectLst/>
+                <a:latin typeface="Arial" panose="020B0604020202020204" pitchFamily="34" charset="0"/>
+              </a:rPr>
+              <a:t>CSRF</a:t>
+            </a:r>
+            <a:r>
+              <a:rPr kumimoji="0" lang="en-US" altLang="en-US" sz="1300" b="0" i="0" u="none" strike="noStrike" cap="none" normalizeH="0" baseline="0">
+                <a:ln>
+                  <a:noFill/>
+                </a:ln>
+                <a:solidFill>
+                  <a:schemeClr val="tx1"/>
+                </a:solidFill>
+                <a:effectLst/>
+                <a:latin typeface="Arial" panose="020B0604020202020204" pitchFamily="34" charset="0"/>
+              </a:rPr>
+              <a:t> tokenini təmsil edir.</a:t>
+            </a:r>
+          </a:p>
+          <a:p>
+            <a:pPr>
+              <a:lnSpc>
+                <a:spcPct val="150000"/>
+              </a:lnSpc>
+              <a:buNone/>
+            </a:pPr>
+            <a:endParaRPr kumimoji="0" lang="az-Latn-AZ" altLang="en-US" sz="1300" b="0" i="0" u="none" strike="noStrike" cap="none" normalizeH="0" baseline="0">
+              <a:ln>
+                <a:noFill/>
+              </a:ln>
+              <a:solidFill>
+                <a:schemeClr val="tx1"/>
+              </a:solidFill>
+              <a:effectLst/>
+              <a:latin typeface="Arial" panose="020B0604020202020204" pitchFamily="34" charset="0"/>
+            </a:endParaRPr>
+          </a:p>
+          <a:p>
+            <a:pPr>
+              <a:lnSpc>
+                <a:spcPct val="150000"/>
+              </a:lnSpc>
+              <a:buNone/>
+            </a:pPr>
+            <a:endParaRPr lang="az-Latn-AZ" altLang="en-US" sz="1300">
+              <a:latin typeface="Arial" panose="020B0604020202020204" pitchFamily="34" charset="0"/>
+            </a:endParaRPr>
+          </a:p>
+          <a:p>
+            <a:pPr>
+              <a:lnSpc>
+                <a:spcPct val="150000"/>
+              </a:lnSpc>
+              <a:buNone/>
+            </a:pPr>
+            <a:endParaRPr kumimoji="0" lang="en-US" altLang="en-US" sz="1300" b="0" i="0" u="none" strike="noStrike" cap="none" normalizeH="0" baseline="0">
+              <a:ln>
+                <a:noFill/>
+              </a:ln>
+              <a:solidFill>
+                <a:schemeClr val="tx1"/>
+              </a:solidFill>
+              <a:effectLst/>
+              <a:latin typeface="Arial" panose="020B0604020202020204" pitchFamily="34" charset="0"/>
+            </a:endParaRPr>
+          </a:p>
+          <a:p>
+            <a:pPr>
+              <a:lnSpc>
+                <a:spcPct val="150000"/>
+              </a:lnSpc>
+              <a:buNone/>
+            </a:pPr>
+            <a:r>
+              <a:rPr kumimoji="0" lang="en-US" altLang="en-US" sz="1300" b="0" i="0" u="none" strike="noStrike" cap="none" normalizeH="0" baseline="0">
+                <a:ln>
+                  <a:noFill/>
+                </a:ln>
+                <a:solidFill>
+                  <a:schemeClr val="tx1"/>
+                </a:solidFill>
+                <a:effectLst/>
+                <a:latin typeface="Arial" panose="020B0604020202020204" pitchFamily="34" charset="0"/>
+              </a:rPr>
+              <a:t>Sessiyada hansısa müəyyən dəyəri çəkmək üçün </a:t>
+            </a:r>
+            <a:r>
+              <a:rPr kumimoji="0" lang="en-US" altLang="en-US" sz="1300" b="1" i="0" u="none" strike="noStrike" cap="none" normalizeH="0" baseline="0">
+                <a:ln>
+                  <a:noFill/>
+                </a:ln>
+                <a:solidFill>
+                  <a:srgbClr val="FF0000"/>
+                </a:solidFill>
+                <a:effectLst/>
+                <a:latin typeface="Arial" panose="020B0604020202020204" pitchFamily="34" charset="0"/>
+              </a:rPr>
+              <a:t>get('key') </a:t>
+            </a:r>
+            <a:r>
+              <a:rPr kumimoji="0" lang="en-US" altLang="en-US" sz="1300" b="0" i="0" u="none" strike="noStrike" cap="none" normalizeH="0" baseline="0">
+                <a:ln>
+                  <a:noFill/>
+                </a:ln>
+                <a:solidFill>
+                  <a:schemeClr val="tx1"/>
+                </a:solidFill>
+                <a:effectLst/>
+                <a:latin typeface="Arial" panose="020B0604020202020204" pitchFamily="34" charset="0"/>
+              </a:rPr>
+              <a:t>istifadə olunur.</a:t>
+            </a:r>
+          </a:p>
+        </p:txBody>
+      </p:sp>
+      <p:pic>
+        <p:nvPicPr>
+          <p:cNvPr id="4" name="Picture 3">
+            <a:extLst>
+              <a:ext uri="{FF2B5EF4-FFF2-40B4-BE49-F238E27FC236}">
+                <a16:creationId xmlns:a16="http://schemas.microsoft.com/office/drawing/2014/main" id="{886A889B-5976-5FF9-A16F-19A956CBC4D9}"/>
+              </a:ext>
+            </a:extLst>
+          </p:cNvPr>
+          <p:cNvPicPr>
+            <a:picLocks noChangeAspect="1"/>
+          </p:cNvPicPr>
+          <p:nvPr/>
+        </p:nvPicPr>
+        <p:blipFill>
+          <a:blip r:embed="rId2"/>
+          <a:stretch>
+            <a:fillRect/>
+          </a:stretch>
+        </p:blipFill>
+        <p:spPr>
+          <a:xfrm>
+            <a:off x="4973860" y="0"/>
+            <a:ext cx="7218140" cy="6858000"/>
+          </a:xfrm>
+          <a:prstGeom prst="rect">
+            <a:avLst/>
+          </a:prstGeom>
+        </p:spPr>
+      </p:pic>
+      <p:pic>
+        <p:nvPicPr>
+          <p:cNvPr id="6" name="Picture 5">
+            <a:extLst>
+              <a:ext uri="{FF2B5EF4-FFF2-40B4-BE49-F238E27FC236}">
+                <a16:creationId xmlns:a16="http://schemas.microsoft.com/office/drawing/2014/main" id="{47CCC96D-597B-4DFA-9B75-DFBC4E152451}"/>
+              </a:ext>
+            </a:extLst>
+          </p:cNvPr>
+          <p:cNvPicPr>
+            <a:picLocks noChangeAspect="1"/>
+          </p:cNvPicPr>
+          <p:nvPr/>
+        </p:nvPicPr>
+        <p:blipFill>
+          <a:blip r:embed="rId3"/>
+          <a:stretch>
+            <a:fillRect/>
+          </a:stretch>
+        </p:blipFill>
+        <p:spPr>
+          <a:xfrm>
+            <a:off x="123502" y="5506053"/>
+            <a:ext cx="4629796" cy="1200318"/>
+          </a:xfrm>
+          <a:prstGeom prst="rect">
+            <a:avLst/>
+          </a:prstGeom>
+          <a:ln w="38100" cap="sq">
+            <a:solidFill>
+              <a:srgbClr val="000000"/>
+            </a:solidFill>
+            <a:prstDash val="solid"/>
+            <a:miter lim="800000"/>
+          </a:ln>
+          <a:effectLst>
+            <a:outerShdw blurRad="50800" dist="38100" dir="2700000" algn="tl" rotWithShape="0">
+              <a:srgbClr val="000000">
+                <a:alpha val="43000"/>
+              </a:srgbClr>
+            </a:outerShdw>
+          </a:effectLst>
+        </p:spPr>
+      </p:pic>
+    </p:spTree>
+    <p:extLst>
+      <p:ext uri="{BB962C8B-B14F-4D97-AF65-F5344CB8AC3E}">
+        <p14:creationId xmlns:p14="http://schemas.microsoft.com/office/powerpoint/2010/main" val="3095838342"/>
+      </p:ext>
+    </p:extLst>
+  </p:cSld>
+  <p:clrMapOvr>
+    <a:masterClrMapping/>
+  </p:clrMapOvr>
+</p:sld>
+</file>
+
+<file path=ppt/slides/slide4.xml><?xml version="1.0" encoding="utf-8"?>
+<p:sld xmlns:a="http://schemas.openxmlformats.org/drawingml/2006/main" xmlns:r="http://schemas.openxmlformats.org/officeDocument/2006/relationships" xmlns:p="http://schemas.openxmlformats.org/presentationml/2006/main">
+  <p:cSld>
+    <p:spTree>
+      <p:nvGrpSpPr>
+        <p:cNvPr id="1" name="">
+          <a:extLst>
+            <a:ext uri="{FF2B5EF4-FFF2-40B4-BE49-F238E27FC236}">
+              <a16:creationId xmlns:a16="http://schemas.microsoft.com/office/drawing/2014/main" id="{C5CF35D9-9593-6A52-8280-5492852C201E}"/>
+            </a:ext>
+          </a:extLst>
+        </p:cNvPr>
+        <p:cNvGrpSpPr/>
+        <p:nvPr/>
+      </p:nvGrpSpPr>
+      <p:grpSpPr>
+        <a:xfrm>
+          <a:off x="0" y="0"/>
+          <a:ext cx="0" cy="0"/>
+          <a:chOff x="0" y="0"/>
+          <a:chExt cx="0" cy="0"/>
+        </a:xfrm>
+      </p:grpSpPr>
+      <p:sp>
+        <p:nvSpPr>
+          <p:cNvPr id="3" name="TextBox 2">
+            <a:extLst>
+              <a:ext uri="{FF2B5EF4-FFF2-40B4-BE49-F238E27FC236}">
+                <a16:creationId xmlns:a16="http://schemas.microsoft.com/office/drawing/2014/main" id="{5F6FAED1-1460-73FE-A636-428E3D887C70}"/>
+              </a:ext>
+            </a:extLst>
+          </p:cNvPr>
+          <p:cNvSpPr txBox="1"/>
+          <p:nvPr/>
+        </p:nvSpPr>
+        <p:spPr>
+          <a:xfrm>
+            <a:off x="217714" y="255046"/>
             <a:ext cx="11756571" cy="355354"/>
           </a:xfrm>
           <a:prstGeom prst="rect">
@@ -3556,10 +4826,2256 @@
           </a:p>
         </p:txBody>
       </p:sp>
+      <p:graphicFrame>
+        <p:nvGraphicFramePr>
+          <p:cNvPr id="2" name="Table 1">
+            <a:extLst>
+              <a:ext uri="{FF2B5EF4-FFF2-40B4-BE49-F238E27FC236}">
+                <a16:creationId xmlns:a16="http://schemas.microsoft.com/office/drawing/2014/main" id="{C9A63B8F-2651-2BFC-BEBD-6E343E3B9898}"/>
+              </a:ext>
+            </a:extLst>
+          </p:cNvPr>
+          <p:cNvGraphicFramePr>
+            <a:graphicFrameLocks noGrp="1"/>
+          </p:cNvGraphicFramePr>
+          <p:nvPr>
+            <p:extLst>
+              <p:ext uri="{D42A27DB-BD31-4B8C-83A1-F6EECF244321}">
+                <p14:modId xmlns:p14="http://schemas.microsoft.com/office/powerpoint/2010/main" val="3993888212"/>
+              </p:ext>
+            </p:extLst>
+          </p:nvPr>
+        </p:nvGraphicFramePr>
+        <p:xfrm>
+          <a:off x="327244" y="1589638"/>
+          <a:ext cx="11537511" cy="3678723"/>
+        </p:xfrm>
+        <a:graphic>
+          <a:graphicData uri="http://schemas.openxmlformats.org/drawingml/2006/table">
+            <a:tbl>
+              <a:tblPr/>
+              <a:tblGrid>
+                <a:gridCol w="817548">
+                  <a:extLst>
+                    <a:ext uri="{9D8B030D-6E8A-4147-A177-3AD203B41FA5}">
+                      <a16:colId xmlns:a16="http://schemas.microsoft.com/office/drawing/2014/main" val="3429029023"/>
+                    </a:ext>
+                  </a:extLst>
+                </a:gridCol>
+                <a:gridCol w="3573321">
+                  <a:extLst>
+                    <a:ext uri="{9D8B030D-6E8A-4147-A177-3AD203B41FA5}">
+                      <a16:colId xmlns:a16="http://schemas.microsoft.com/office/drawing/2014/main" val="3708441085"/>
+                    </a:ext>
+                  </a:extLst>
+                </a:gridCol>
+                <a:gridCol w="3573321">
+                  <a:extLst>
+                    <a:ext uri="{9D8B030D-6E8A-4147-A177-3AD203B41FA5}">
+                      <a16:colId xmlns:a16="http://schemas.microsoft.com/office/drawing/2014/main" val="2363330964"/>
+                    </a:ext>
+                  </a:extLst>
+                </a:gridCol>
+                <a:gridCol w="3573321">
+                  <a:extLst>
+                    <a:ext uri="{9D8B030D-6E8A-4147-A177-3AD203B41FA5}">
+                      <a16:colId xmlns:a16="http://schemas.microsoft.com/office/drawing/2014/main" val="2023895659"/>
+                    </a:ext>
+                  </a:extLst>
+                </a:gridCol>
+              </a:tblGrid>
+              <a:tr h="774468">
+                <a:tc>
+                  <a:txBody>
+                    <a:bodyPr/>
+                    <a:lstStyle/>
+                    <a:p>
+                      <a:r>
+                        <a:rPr lang="en-US" b="1"/>
+                        <a:t>Kod</a:t>
+                      </a:r>
+                    </a:p>
+                  </a:txBody>
+                  <a:tcPr anchor="ctr">
+                    <a:lnL w="12700" cap="flat" cmpd="sng" algn="ctr">
+                      <a:solidFill>
+                        <a:schemeClr val="tx1"/>
+                      </a:solidFill>
+                      <a:prstDash val="solid"/>
+                      <a:round/>
+                      <a:headEnd type="none" w="med" len="med"/>
+                      <a:tailEnd type="none" w="med" len="med"/>
+                    </a:lnL>
+                    <a:lnR w="12700" cap="flat" cmpd="sng" algn="ctr">
+                      <a:solidFill>
+                        <a:schemeClr val="tx1"/>
+                      </a:solidFill>
+                      <a:prstDash val="solid"/>
+                      <a:round/>
+                      <a:headEnd type="none" w="med" len="med"/>
+                      <a:tailEnd type="none" w="med" len="med"/>
+                    </a:lnR>
+                    <a:lnT w="12700" cap="flat" cmpd="sng" algn="ctr">
+                      <a:solidFill>
+                        <a:schemeClr val="tx1"/>
+                      </a:solidFill>
+                      <a:prstDash val="solid"/>
+                      <a:round/>
+                      <a:headEnd type="none" w="med" len="med"/>
+                      <a:tailEnd type="none" w="med" len="med"/>
+                    </a:lnT>
+                    <a:lnB w="12700" cap="flat" cmpd="sng" algn="ctr">
+                      <a:solidFill>
+                        <a:schemeClr val="tx1"/>
+                      </a:solidFill>
+                      <a:prstDash val="solid"/>
+                      <a:round/>
+                      <a:headEnd type="none" w="med" len="med"/>
+                      <a:tailEnd type="none" w="med" len="med"/>
+                    </a:lnB>
+                    <a:solidFill>
+                      <a:schemeClr val="accent2"/>
+                    </a:solidFill>
+                  </a:tcPr>
+                </a:tc>
+                <a:tc>
+                  <a:txBody>
+                    <a:bodyPr/>
+                    <a:lstStyle/>
+                    <a:p>
+                      <a:r>
+                        <a:rPr lang="en-US" b="1"/>
+                        <a:t>Sessiyaya giriş yolu</a:t>
+                      </a:r>
+                    </a:p>
+                  </a:txBody>
+                  <a:tcPr anchor="ctr">
+                    <a:lnL w="12700" cap="flat" cmpd="sng" algn="ctr">
+                      <a:solidFill>
+                        <a:schemeClr val="tx1"/>
+                      </a:solidFill>
+                      <a:prstDash val="solid"/>
+                      <a:round/>
+                      <a:headEnd type="none" w="med" len="med"/>
+                      <a:tailEnd type="none" w="med" len="med"/>
+                    </a:lnL>
+                    <a:lnR w="12700" cap="flat" cmpd="sng" algn="ctr">
+                      <a:solidFill>
+                        <a:schemeClr val="tx1"/>
+                      </a:solidFill>
+                      <a:prstDash val="solid"/>
+                      <a:round/>
+                      <a:headEnd type="none" w="med" len="med"/>
+                      <a:tailEnd type="none" w="med" len="med"/>
+                    </a:lnR>
+                    <a:lnT w="12700" cap="flat" cmpd="sng" algn="ctr">
+                      <a:solidFill>
+                        <a:schemeClr val="tx1"/>
+                      </a:solidFill>
+                      <a:prstDash val="solid"/>
+                      <a:round/>
+                      <a:headEnd type="none" w="med" len="med"/>
+                      <a:tailEnd type="none" w="med" len="med"/>
+                    </a:lnT>
+                    <a:lnB w="12700" cap="flat" cmpd="sng" algn="ctr">
+                      <a:solidFill>
+                        <a:schemeClr val="tx1"/>
+                      </a:solidFill>
+                      <a:prstDash val="solid"/>
+                      <a:round/>
+                      <a:headEnd type="none" w="med" len="med"/>
+                      <a:tailEnd type="none" w="med" len="med"/>
+                    </a:lnB>
+                    <a:solidFill>
+                      <a:schemeClr val="accent2"/>
+                    </a:solidFill>
+                  </a:tcPr>
+                </a:tc>
+                <a:tc>
+                  <a:txBody>
+                    <a:bodyPr/>
+                    <a:lstStyle/>
+                    <a:p>
+                      <a:r>
+                        <a:rPr lang="en-US" b="1"/>
+                        <a:t>Nə alır</a:t>
+                      </a:r>
+                    </a:p>
+                  </a:txBody>
+                  <a:tcPr anchor="ctr">
+                    <a:lnL w="12700" cap="flat" cmpd="sng" algn="ctr">
+                      <a:solidFill>
+                        <a:schemeClr val="tx1"/>
+                      </a:solidFill>
+                      <a:prstDash val="solid"/>
+                      <a:round/>
+                      <a:headEnd type="none" w="med" len="med"/>
+                      <a:tailEnd type="none" w="med" len="med"/>
+                    </a:lnL>
+                    <a:lnR w="12700" cap="flat" cmpd="sng" algn="ctr">
+                      <a:solidFill>
+                        <a:schemeClr val="tx1"/>
+                      </a:solidFill>
+                      <a:prstDash val="solid"/>
+                      <a:round/>
+                      <a:headEnd type="none" w="med" len="med"/>
+                      <a:tailEnd type="none" w="med" len="med"/>
+                    </a:lnR>
+                    <a:lnT w="12700" cap="flat" cmpd="sng" algn="ctr">
+                      <a:solidFill>
+                        <a:schemeClr val="tx1"/>
+                      </a:solidFill>
+                      <a:prstDash val="solid"/>
+                      <a:round/>
+                      <a:headEnd type="none" w="med" len="med"/>
+                      <a:tailEnd type="none" w="med" len="med"/>
+                    </a:lnT>
+                    <a:lnB w="12700" cap="flat" cmpd="sng" algn="ctr">
+                      <a:solidFill>
+                        <a:schemeClr val="tx1"/>
+                      </a:solidFill>
+                      <a:prstDash val="solid"/>
+                      <a:round/>
+                      <a:headEnd type="none" w="med" len="med"/>
+                      <a:tailEnd type="none" w="med" len="med"/>
+                    </a:lnB>
+                    <a:solidFill>
+                      <a:schemeClr val="accent2"/>
+                    </a:solidFill>
+                  </a:tcPr>
+                </a:tc>
+                <a:tc>
+                  <a:txBody>
+                    <a:bodyPr/>
+                    <a:lstStyle/>
+                    <a:p>
+                      <a:r>
+                        <a:rPr lang="en-US" b="1"/>
+                        <a:t>Qeyd</a:t>
+                      </a:r>
+                    </a:p>
+                  </a:txBody>
+                  <a:tcPr anchor="ctr">
+                    <a:lnL w="12700" cap="flat" cmpd="sng" algn="ctr">
+                      <a:solidFill>
+                        <a:schemeClr val="tx1"/>
+                      </a:solidFill>
+                      <a:prstDash val="solid"/>
+                      <a:round/>
+                      <a:headEnd type="none" w="med" len="med"/>
+                      <a:tailEnd type="none" w="med" len="med"/>
+                    </a:lnL>
+                    <a:lnR w="12700" cap="flat" cmpd="sng" algn="ctr">
+                      <a:solidFill>
+                        <a:schemeClr val="tx1"/>
+                      </a:solidFill>
+                      <a:prstDash val="solid"/>
+                      <a:round/>
+                      <a:headEnd type="none" w="med" len="med"/>
+                      <a:tailEnd type="none" w="med" len="med"/>
+                    </a:lnR>
+                    <a:lnT w="12700" cap="flat" cmpd="sng" algn="ctr">
+                      <a:solidFill>
+                        <a:schemeClr val="tx1"/>
+                      </a:solidFill>
+                      <a:prstDash val="solid"/>
+                      <a:round/>
+                      <a:headEnd type="none" w="med" len="med"/>
+                      <a:tailEnd type="none" w="med" len="med"/>
+                    </a:lnT>
+                    <a:lnB w="12700" cap="flat" cmpd="sng" algn="ctr">
+                      <a:solidFill>
+                        <a:schemeClr val="tx1"/>
+                      </a:solidFill>
+                      <a:prstDash val="solid"/>
+                      <a:round/>
+                      <a:headEnd type="none" w="med" len="med"/>
+                      <a:tailEnd type="none" w="med" len="med"/>
+                    </a:lnB>
+                    <a:solidFill>
+                      <a:schemeClr val="accent2"/>
+                    </a:solidFill>
+                  </a:tcPr>
+                </a:tc>
+                <a:extLst>
+                  <a:ext uri="{0D108BD9-81ED-4DB2-BD59-A6C34878D82A}">
+                    <a16:rowId xmlns:a16="http://schemas.microsoft.com/office/drawing/2014/main" val="1597534874"/>
+                  </a:ext>
+                </a:extLst>
+              </a:tr>
+              <a:tr h="774468">
+                <a:tc>
+                  <a:txBody>
+                    <a:bodyPr/>
+                    <a:lstStyle/>
+                    <a:p>
+                      <a:r>
+                        <a:rPr lang="en-US" b="1"/>
+                        <a:t>a)</a:t>
+                      </a:r>
+                      <a:endParaRPr lang="en-US"/>
+                    </a:p>
+                  </a:txBody>
+                  <a:tcPr anchor="ctr">
+                    <a:lnL w="12700" cap="flat" cmpd="sng" algn="ctr">
+                      <a:solidFill>
+                        <a:schemeClr val="tx1"/>
+                      </a:solidFill>
+                      <a:prstDash val="solid"/>
+                      <a:round/>
+                      <a:headEnd type="none" w="med" len="med"/>
+                      <a:tailEnd type="none" w="med" len="med"/>
+                    </a:lnL>
+                    <a:lnR w="12700" cap="flat" cmpd="sng" algn="ctr">
+                      <a:solidFill>
+                        <a:schemeClr val="tx1"/>
+                      </a:solidFill>
+                      <a:prstDash val="solid"/>
+                      <a:round/>
+                      <a:headEnd type="none" w="med" len="med"/>
+                      <a:tailEnd type="none" w="med" len="med"/>
+                    </a:lnR>
+                    <a:lnT w="12700" cap="flat" cmpd="sng" algn="ctr">
+                      <a:solidFill>
+                        <a:schemeClr val="tx1"/>
+                      </a:solidFill>
+                      <a:prstDash val="solid"/>
+                      <a:round/>
+                      <a:headEnd type="none" w="med" len="med"/>
+                      <a:tailEnd type="none" w="med" len="med"/>
+                    </a:lnT>
+                    <a:lnB w="12700" cap="flat" cmpd="sng" algn="ctr">
+                      <a:solidFill>
+                        <a:schemeClr val="tx1"/>
+                      </a:solidFill>
+                      <a:prstDash val="solid"/>
+                      <a:round/>
+                      <a:headEnd type="none" w="med" len="med"/>
+                      <a:tailEnd type="none" w="med" len="med"/>
+                    </a:lnB>
+                    <a:noFill/>
+                  </a:tcPr>
+                </a:tc>
+                <a:tc>
+                  <a:txBody>
+                    <a:bodyPr/>
+                    <a:lstStyle/>
+                    <a:p>
+                      <a:r>
+                        <a:rPr lang="en-US"/>
+                        <a:t>session()-&gt;all()</a:t>
+                      </a:r>
+                    </a:p>
+                  </a:txBody>
+                  <a:tcPr anchor="ctr">
+                    <a:lnL w="12700" cap="flat" cmpd="sng" algn="ctr">
+                      <a:solidFill>
+                        <a:schemeClr val="tx1"/>
+                      </a:solidFill>
+                      <a:prstDash val="solid"/>
+                      <a:round/>
+                      <a:headEnd type="none" w="med" len="med"/>
+                      <a:tailEnd type="none" w="med" len="med"/>
+                    </a:lnL>
+                    <a:lnR w="12700" cap="flat" cmpd="sng" algn="ctr">
+                      <a:solidFill>
+                        <a:schemeClr val="tx1"/>
+                      </a:solidFill>
+                      <a:prstDash val="solid"/>
+                      <a:round/>
+                      <a:headEnd type="none" w="med" len="med"/>
+                      <a:tailEnd type="none" w="med" len="med"/>
+                    </a:lnR>
+                    <a:lnT w="12700" cap="flat" cmpd="sng" algn="ctr">
+                      <a:solidFill>
+                        <a:schemeClr val="tx1"/>
+                      </a:solidFill>
+                      <a:prstDash val="solid"/>
+                      <a:round/>
+                      <a:headEnd type="none" w="med" len="med"/>
+                      <a:tailEnd type="none" w="med" len="med"/>
+                    </a:lnT>
+                    <a:lnB w="12700" cap="flat" cmpd="sng" algn="ctr">
+                      <a:solidFill>
+                        <a:schemeClr val="tx1"/>
+                      </a:solidFill>
+                      <a:prstDash val="solid"/>
+                      <a:round/>
+                      <a:headEnd type="none" w="med" len="med"/>
+                      <a:tailEnd type="none" w="med" len="med"/>
+                    </a:lnB>
+                    <a:noFill/>
+                  </a:tcPr>
+                </a:tc>
+                <a:tc>
+                  <a:txBody>
+                    <a:bodyPr/>
+                    <a:lstStyle/>
+                    <a:p>
+                      <a:r>
+                        <a:rPr lang="en-US"/>
+                        <a:t>Bütün sessiya məlumatları</a:t>
+                      </a:r>
+                    </a:p>
+                  </a:txBody>
+                  <a:tcPr anchor="ctr">
+                    <a:lnL w="12700" cap="flat" cmpd="sng" algn="ctr">
+                      <a:solidFill>
+                        <a:schemeClr val="tx1"/>
+                      </a:solidFill>
+                      <a:prstDash val="solid"/>
+                      <a:round/>
+                      <a:headEnd type="none" w="med" len="med"/>
+                      <a:tailEnd type="none" w="med" len="med"/>
+                    </a:lnL>
+                    <a:lnR w="12700" cap="flat" cmpd="sng" algn="ctr">
+                      <a:solidFill>
+                        <a:schemeClr val="tx1"/>
+                      </a:solidFill>
+                      <a:prstDash val="solid"/>
+                      <a:round/>
+                      <a:headEnd type="none" w="med" len="med"/>
+                      <a:tailEnd type="none" w="med" len="med"/>
+                    </a:lnR>
+                    <a:lnT w="12700" cap="flat" cmpd="sng" algn="ctr">
+                      <a:solidFill>
+                        <a:schemeClr val="tx1"/>
+                      </a:solidFill>
+                      <a:prstDash val="solid"/>
+                      <a:round/>
+                      <a:headEnd type="none" w="med" len="med"/>
+                      <a:tailEnd type="none" w="med" len="med"/>
+                    </a:lnT>
+                    <a:lnB w="12700" cap="flat" cmpd="sng" algn="ctr">
+                      <a:solidFill>
+                        <a:schemeClr val="tx1"/>
+                      </a:solidFill>
+                      <a:prstDash val="solid"/>
+                      <a:round/>
+                      <a:headEnd type="none" w="med" len="med"/>
+                      <a:tailEnd type="none" w="med" len="med"/>
+                    </a:lnB>
+                    <a:noFill/>
+                  </a:tcPr>
+                </a:tc>
+                <a:tc>
+                  <a:txBody>
+                    <a:bodyPr/>
+                    <a:lstStyle/>
+                    <a:p>
+                      <a:r>
+                        <a:rPr lang="en-US"/>
+                        <a:t>Qlobal helper, qısa yazılış</a:t>
+                      </a:r>
+                    </a:p>
+                  </a:txBody>
+                  <a:tcPr anchor="ctr">
+                    <a:lnL w="12700" cap="flat" cmpd="sng" algn="ctr">
+                      <a:solidFill>
+                        <a:schemeClr val="tx1"/>
+                      </a:solidFill>
+                      <a:prstDash val="solid"/>
+                      <a:round/>
+                      <a:headEnd type="none" w="med" len="med"/>
+                      <a:tailEnd type="none" w="med" len="med"/>
+                    </a:lnL>
+                    <a:lnR w="12700" cap="flat" cmpd="sng" algn="ctr">
+                      <a:solidFill>
+                        <a:schemeClr val="tx1"/>
+                      </a:solidFill>
+                      <a:prstDash val="solid"/>
+                      <a:round/>
+                      <a:headEnd type="none" w="med" len="med"/>
+                      <a:tailEnd type="none" w="med" len="med"/>
+                    </a:lnR>
+                    <a:lnT w="12700" cap="flat" cmpd="sng" algn="ctr">
+                      <a:solidFill>
+                        <a:schemeClr val="tx1"/>
+                      </a:solidFill>
+                      <a:prstDash val="solid"/>
+                      <a:round/>
+                      <a:headEnd type="none" w="med" len="med"/>
+                      <a:tailEnd type="none" w="med" len="med"/>
+                    </a:lnT>
+                    <a:lnB w="12700" cap="flat" cmpd="sng" algn="ctr">
+                      <a:solidFill>
+                        <a:schemeClr val="tx1"/>
+                      </a:solidFill>
+                      <a:prstDash val="solid"/>
+                      <a:round/>
+                      <a:headEnd type="none" w="med" len="med"/>
+                      <a:tailEnd type="none" w="med" len="med"/>
+                    </a:lnB>
+                    <a:noFill/>
+                  </a:tcPr>
+                </a:tc>
+                <a:extLst>
+                  <a:ext uri="{0D108BD9-81ED-4DB2-BD59-A6C34878D82A}">
+                    <a16:rowId xmlns:a16="http://schemas.microsoft.com/office/drawing/2014/main" val="2441180995"/>
+                  </a:ext>
+                </a:extLst>
+              </a:tr>
+              <a:tr h="1355319">
+                <a:tc>
+                  <a:txBody>
+                    <a:bodyPr/>
+                    <a:lstStyle/>
+                    <a:p>
+                      <a:r>
+                        <a:rPr lang="en-US" b="1"/>
+                        <a:t>b)</a:t>
+                      </a:r>
+                      <a:endParaRPr lang="en-US"/>
+                    </a:p>
+                  </a:txBody>
+                  <a:tcPr anchor="ctr">
+                    <a:lnL w="12700" cap="flat" cmpd="sng" algn="ctr">
+                      <a:solidFill>
+                        <a:schemeClr val="tx1"/>
+                      </a:solidFill>
+                      <a:prstDash val="solid"/>
+                      <a:round/>
+                      <a:headEnd type="none" w="med" len="med"/>
+                      <a:tailEnd type="none" w="med" len="med"/>
+                    </a:lnL>
+                    <a:lnR w="12700" cap="flat" cmpd="sng" algn="ctr">
+                      <a:solidFill>
+                        <a:schemeClr val="tx1"/>
+                      </a:solidFill>
+                      <a:prstDash val="solid"/>
+                      <a:round/>
+                      <a:headEnd type="none" w="med" len="med"/>
+                      <a:tailEnd type="none" w="med" len="med"/>
+                    </a:lnR>
+                    <a:lnT w="12700" cap="flat" cmpd="sng" algn="ctr">
+                      <a:solidFill>
+                        <a:schemeClr val="tx1"/>
+                      </a:solidFill>
+                      <a:prstDash val="solid"/>
+                      <a:round/>
+                      <a:headEnd type="none" w="med" len="med"/>
+                      <a:tailEnd type="none" w="med" len="med"/>
+                    </a:lnT>
+                    <a:lnB w="12700" cap="flat" cmpd="sng" algn="ctr">
+                      <a:solidFill>
+                        <a:schemeClr val="tx1"/>
+                      </a:solidFill>
+                      <a:prstDash val="solid"/>
+                      <a:round/>
+                      <a:headEnd type="none" w="med" len="med"/>
+                      <a:tailEnd type="none" w="med" len="med"/>
+                    </a:lnB>
+                    <a:noFill/>
+                  </a:tcPr>
+                </a:tc>
+                <a:tc>
+                  <a:txBody>
+                    <a:bodyPr/>
+                    <a:lstStyle/>
+                    <a:p>
+                      <a:r>
+                        <a:rPr lang="en-US"/>
+                        <a:t>$request-&gt;session()-&gt;all()</a:t>
+                      </a:r>
+                    </a:p>
+                  </a:txBody>
+                  <a:tcPr anchor="ctr">
+                    <a:lnL w="12700" cap="flat" cmpd="sng" algn="ctr">
+                      <a:solidFill>
+                        <a:schemeClr val="tx1"/>
+                      </a:solidFill>
+                      <a:prstDash val="solid"/>
+                      <a:round/>
+                      <a:headEnd type="none" w="med" len="med"/>
+                      <a:tailEnd type="none" w="med" len="med"/>
+                    </a:lnL>
+                    <a:lnR w="12700" cap="flat" cmpd="sng" algn="ctr">
+                      <a:solidFill>
+                        <a:schemeClr val="tx1"/>
+                      </a:solidFill>
+                      <a:prstDash val="solid"/>
+                      <a:round/>
+                      <a:headEnd type="none" w="med" len="med"/>
+                      <a:tailEnd type="none" w="med" len="med"/>
+                    </a:lnR>
+                    <a:lnT w="12700" cap="flat" cmpd="sng" algn="ctr">
+                      <a:solidFill>
+                        <a:schemeClr val="tx1"/>
+                      </a:solidFill>
+                      <a:prstDash val="solid"/>
+                      <a:round/>
+                      <a:headEnd type="none" w="med" len="med"/>
+                      <a:tailEnd type="none" w="med" len="med"/>
+                    </a:lnT>
+                    <a:lnB w="12700" cap="flat" cmpd="sng" algn="ctr">
+                      <a:solidFill>
+                        <a:schemeClr val="tx1"/>
+                      </a:solidFill>
+                      <a:prstDash val="solid"/>
+                      <a:round/>
+                      <a:headEnd type="none" w="med" len="med"/>
+                      <a:tailEnd type="none" w="med" len="med"/>
+                    </a:lnB>
+                    <a:noFill/>
+                  </a:tcPr>
+                </a:tc>
+                <a:tc>
+                  <a:txBody>
+                    <a:bodyPr/>
+                    <a:lstStyle/>
+                    <a:p>
+                      <a:r>
+                        <a:rPr lang="en-US"/>
+                        <a:t>Bütün sessiya məlumatları</a:t>
+                      </a:r>
+                    </a:p>
+                  </a:txBody>
+                  <a:tcPr anchor="ctr">
+                    <a:lnL w="12700" cap="flat" cmpd="sng" algn="ctr">
+                      <a:solidFill>
+                        <a:schemeClr val="tx1"/>
+                      </a:solidFill>
+                      <a:prstDash val="solid"/>
+                      <a:round/>
+                      <a:headEnd type="none" w="med" len="med"/>
+                      <a:tailEnd type="none" w="med" len="med"/>
+                    </a:lnL>
+                    <a:lnR w="12700" cap="flat" cmpd="sng" algn="ctr">
+                      <a:solidFill>
+                        <a:schemeClr val="tx1"/>
+                      </a:solidFill>
+                      <a:prstDash val="solid"/>
+                      <a:round/>
+                      <a:headEnd type="none" w="med" len="med"/>
+                      <a:tailEnd type="none" w="med" len="med"/>
+                    </a:lnR>
+                    <a:lnT w="12700" cap="flat" cmpd="sng" algn="ctr">
+                      <a:solidFill>
+                        <a:schemeClr val="tx1"/>
+                      </a:solidFill>
+                      <a:prstDash val="solid"/>
+                      <a:round/>
+                      <a:headEnd type="none" w="med" len="med"/>
+                      <a:tailEnd type="none" w="med" len="med"/>
+                    </a:lnT>
+                    <a:lnB w="12700" cap="flat" cmpd="sng" algn="ctr">
+                      <a:solidFill>
+                        <a:schemeClr val="tx1"/>
+                      </a:solidFill>
+                      <a:prstDash val="solid"/>
+                      <a:round/>
+                      <a:headEnd type="none" w="med" len="med"/>
+                      <a:tailEnd type="none" w="med" len="med"/>
+                    </a:lnB>
+                    <a:noFill/>
+                  </a:tcPr>
+                </a:tc>
+                <a:tc>
+                  <a:txBody>
+                    <a:bodyPr/>
+                    <a:lstStyle/>
+                    <a:p>
+                      <a:r>
+                        <a:rPr lang="en-US"/>
+                        <a:t>Request ilə birlikdə işləmək üçün uyğundur</a:t>
+                      </a:r>
+                    </a:p>
+                  </a:txBody>
+                  <a:tcPr anchor="ctr">
+                    <a:lnL w="12700" cap="flat" cmpd="sng" algn="ctr">
+                      <a:solidFill>
+                        <a:schemeClr val="tx1"/>
+                      </a:solidFill>
+                      <a:prstDash val="solid"/>
+                      <a:round/>
+                      <a:headEnd type="none" w="med" len="med"/>
+                      <a:tailEnd type="none" w="med" len="med"/>
+                    </a:lnL>
+                    <a:lnR w="12700" cap="flat" cmpd="sng" algn="ctr">
+                      <a:solidFill>
+                        <a:schemeClr val="tx1"/>
+                      </a:solidFill>
+                      <a:prstDash val="solid"/>
+                      <a:round/>
+                      <a:headEnd type="none" w="med" len="med"/>
+                      <a:tailEnd type="none" w="med" len="med"/>
+                    </a:lnR>
+                    <a:lnT w="12700" cap="flat" cmpd="sng" algn="ctr">
+                      <a:solidFill>
+                        <a:schemeClr val="tx1"/>
+                      </a:solidFill>
+                      <a:prstDash val="solid"/>
+                      <a:round/>
+                      <a:headEnd type="none" w="med" len="med"/>
+                      <a:tailEnd type="none" w="med" len="med"/>
+                    </a:lnT>
+                    <a:lnB w="12700" cap="flat" cmpd="sng" algn="ctr">
+                      <a:solidFill>
+                        <a:schemeClr val="tx1"/>
+                      </a:solidFill>
+                      <a:prstDash val="solid"/>
+                      <a:round/>
+                      <a:headEnd type="none" w="med" len="med"/>
+                      <a:tailEnd type="none" w="med" len="med"/>
+                    </a:lnB>
+                    <a:noFill/>
+                  </a:tcPr>
+                </a:tc>
+                <a:extLst>
+                  <a:ext uri="{0D108BD9-81ED-4DB2-BD59-A6C34878D82A}">
+                    <a16:rowId xmlns:a16="http://schemas.microsoft.com/office/drawing/2014/main" val="595293916"/>
+                  </a:ext>
+                </a:extLst>
+              </a:tr>
+              <a:tr h="774468">
+                <a:tc>
+                  <a:txBody>
+                    <a:bodyPr/>
+                    <a:lstStyle/>
+                    <a:p>
+                      <a:r>
+                        <a:rPr lang="en-US" b="1"/>
+                        <a:t>c)</a:t>
+                      </a:r>
+                      <a:endParaRPr lang="en-US"/>
+                    </a:p>
+                  </a:txBody>
+                  <a:tcPr anchor="ctr">
+                    <a:lnL w="12700" cap="flat" cmpd="sng" algn="ctr">
+                      <a:solidFill>
+                        <a:schemeClr val="tx1"/>
+                      </a:solidFill>
+                      <a:prstDash val="solid"/>
+                      <a:round/>
+                      <a:headEnd type="none" w="med" len="med"/>
+                      <a:tailEnd type="none" w="med" len="med"/>
+                    </a:lnL>
+                    <a:lnR w="12700" cap="flat" cmpd="sng" algn="ctr">
+                      <a:solidFill>
+                        <a:schemeClr val="tx1"/>
+                      </a:solidFill>
+                      <a:prstDash val="solid"/>
+                      <a:round/>
+                      <a:headEnd type="none" w="med" len="med"/>
+                      <a:tailEnd type="none" w="med" len="med"/>
+                    </a:lnR>
+                    <a:lnT w="12700" cap="flat" cmpd="sng" algn="ctr">
+                      <a:solidFill>
+                        <a:schemeClr val="tx1"/>
+                      </a:solidFill>
+                      <a:prstDash val="solid"/>
+                      <a:round/>
+                      <a:headEnd type="none" w="med" len="med"/>
+                      <a:tailEnd type="none" w="med" len="med"/>
+                    </a:lnT>
+                    <a:lnB w="12700" cap="flat" cmpd="sng" algn="ctr">
+                      <a:solidFill>
+                        <a:schemeClr val="tx1"/>
+                      </a:solidFill>
+                      <a:prstDash val="solid"/>
+                      <a:round/>
+                      <a:headEnd type="none" w="med" len="med"/>
+                      <a:tailEnd type="none" w="med" len="med"/>
+                    </a:lnB>
+                    <a:noFill/>
+                  </a:tcPr>
+                </a:tc>
+                <a:tc>
+                  <a:txBody>
+                    <a:bodyPr/>
+                    <a:lstStyle/>
+                    <a:p>
+                      <a:r>
+                        <a:rPr lang="en-US"/>
+                        <a:t>$request-&gt;session()-&gt;get('_token')</a:t>
+                      </a:r>
+                    </a:p>
+                  </a:txBody>
+                  <a:tcPr anchor="ctr">
+                    <a:lnL w="12700" cap="flat" cmpd="sng" algn="ctr">
+                      <a:solidFill>
+                        <a:schemeClr val="tx1"/>
+                      </a:solidFill>
+                      <a:prstDash val="solid"/>
+                      <a:round/>
+                      <a:headEnd type="none" w="med" len="med"/>
+                      <a:tailEnd type="none" w="med" len="med"/>
+                    </a:lnL>
+                    <a:lnR w="12700" cap="flat" cmpd="sng" algn="ctr">
+                      <a:solidFill>
+                        <a:schemeClr val="tx1"/>
+                      </a:solidFill>
+                      <a:prstDash val="solid"/>
+                      <a:round/>
+                      <a:headEnd type="none" w="med" len="med"/>
+                      <a:tailEnd type="none" w="med" len="med"/>
+                    </a:lnR>
+                    <a:lnT w="12700" cap="flat" cmpd="sng" algn="ctr">
+                      <a:solidFill>
+                        <a:schemeClr val="tx1"/>
+                      </a:solidFill>
+                      <a:prstDash val="solid"/>
+                      <a:round/>
+                      <a:headEnd type="none" w="med" len="med"/>
+                      <a:tailEnd type="none" w="med" len="med"/>
+                    </a:lnT>
+                    <a:lnB w="12700" cap="flat" cmpd="sng" algn="ctr">
+                      <a:solidFill>
+                        <a:schemeClr val="tx1"/>
+                      </a:solidFill>
+                      <a:prstDash val="solid"/>
+                      <a:round/>
+                      <a:headEnd type="none" w="med" len="med"/>
+                      <a:tailEnd type="none" w="med" len="med"/>
+                    </a:lnB>
+                    <a:noFill/>
+                  </a:tcPr>
+                </a:tc>
+                <a:tc>
+                  <a:txBody>
+                    <a:bodyPr/>
+                    <a:lstStyle/>
+                    <a:p>
+                      <a:r>
+                        <a:rPr lang="en-US"/>
+                        <a:t>Tək bir açar üzrə məlumat</a:t>
+                      </a:r>
+                    </a:p>
+                  </a:txBody>
+                  <a:tcPr anchor="ctr">
+                    <a:lnL w="12700" cap="flat" cmpd="sng" algn="ctr">
+                      <a:solidFill>
+                        <a:schemeClr val="tx1"/>
+                      </a:solidFill>
+                      <a:prstDash val="solid"/>
+                      <a:round/>
+                      <a:headEnd type="none" w="med" len="med"/>
+                      <a:tailEnd type="none" w="med" len="med"/>
+                    </a:lnL>
+                    <a:lnR w="12700" cap="flat" cmpd="sng" algn="ctr">
+                      <a:solidFill>
+                        <a:schemeClr val="tx1"/>
+                      </a:solidFill>
+                      <a:prstDash val="solid"/>
+                      <a:round/>
+                      <a:headEnd type="none" w="med" len="med"/>
+                      <a:tailEnd type="none" w="med" len="med"/>
+                    </a:lnR>
+                    <a:lnT w="12700" cap="flat" cmpd="sng" algn="ctr">
+                      <a:solidFill>
+                        <a:schemeClr val="tx1"/>
+                      </a:solidFill>
+                      <a:prstDash val="solid"/>
+                      <a:round/>
+                      <a:headEnd type="none" w="med" len="med"/>
+                      <a:tailEnd type="none" w="med" len="med"/>
+                    </a:lnT>
+                    <a:lnB w="12700" cap="flat" cmpd="sng" algn="ctr">
+                      <a:solidFill>
+                        <a:schemeClr val="tx1"/>
+                      </a:solidFill>
+                      <a:prstDash val="solid"/>
+                      <a:round/>
+                      <a:headEnd type="none" w="med" len="med"/>
+                      <a:tailEnd type="none" w="med" len="med"/>
+                    </a:lnB>
+                    <a:noFill/>
+                  </a:tcPr>
+                </a:tc>
+                <a:tc>
+                  <a:txBody>
+                    <a:bodyPr/>
+                    <a:lstStyle/>
+                    <a:p>
+                      <a:r>
+                        <a:rPr lang="en-US"/>
+                        <a:t>Konkret sessiya dəyəri almaq üçün</a:t>
+                      </a:r>
+                    </a:p>
+                  </a:txBody>
+                  <a:tcPr anchor="ctr">
+                    <a:lnL w="12700" cap="flat" cmpd="sng" algn="ctr">
+                      <a:solidFill>
+                        <a:schemeClr val="tx1"/>
+                      </a:solidFill>
+                      <a:prstDash val="solid"/>
+                      <a:round/>
+                      <a:headEnd type="none" w="med" len="med"/>
+                      <a:tailEnd type="none" w="med" len="med"/>
+                    </a:lnL>
+                    <a:lnR w="12700" cap="flat" cmpd="sng" algn="ctr">
+                      <a:solidFill>
+                        <a:schemeClr val="tx1"/>
+                      </a:solidFill>
+                      <a:prstDash val="solid"/>
+                      <a:round/>
+                      <a:headEnd type="none" w="med" len="med"/>
+                      <a:tailEnd type="none" w="med" len="med"/>
+                    </a:lnR>
+                    <a:lnT w="12700" cap="flat" cmpd="sng" algn="ctr">
+                      <a:solidFill>
+                        <a:schemeClr val="tx1"/>
+                      </a:solidFill>
+                      <a:prstDash val="solid"/>
+                      <a:round/>
+                      <a:headEnd type="none" w="med" len="med"/>
+                      <a:tailEnd type="none" w="med" len="med"/>
+                    </a:lnT>
+                    <a:lnB w="12700" cap="flat" cmpd="sng" algn="ctr">
+                      <a:solidFill>
+                        <a:schemeClr val="tx1"/>
+                      </a:solidFill>
+                      <a:prstDash val="solid"/>
+                      <a:round/>
+                      <a:headEnd type="none" w="med" len="med"/>
+                      <a:tailEnd type="none" w="med" len="med"/>
+                    </a:lnB>
+                    <a:noFill/>
+                  </a:tcPr>
+                </a:tc>
+                <a:extLst>
+                  <a:ext uri="{0D108BD9-81ED-4DB2-BD59-A6C34878D82A}">
+                    <a16:rowId xmlns:a16="http://schemas.microsoft.com/office/drawing/2014/main" val="2842276750"/>
+                  </a:ext>
+                </a:extLst>
+              </a:tr>
+            </a:tbl>
+          </a:graphicData>
+        </a:graphic>
+      </p:graphicFrame>
     </p:spTree>
     <p:extLst>
       <p:ext uri="{BB962C8B-B14F-4D97-AF65-F5344CB8AC3E}">
-        <p14:creationId xmlns:p14="http://schemas.microsoft.com/office/powerpoint/2010/main" val="3095838342"/>
+        <p14:creationId xmlns:p14="http://schemas.microsoft.com/office/powerpoint/2010/main" val="2693662835"/>
+      </p:ext>
+    </p:extLst>
+  </p:cSld>
+  <p:clrMapOvr>
+    <a:masterClrMapping/>
+  </p:clrMapOvr>
+</p:sld>
+</file>
+
+<file path=ppt/slides/slide5.xml><?xml version="1.0" encoding="utf-8"?>
+<p:sld xmlns:a="http://schemas.openxmlformats.org/drawingml/2006/main" xmlns:r="http://schemas.openxmlformats.org/officeDocument/2006/relationships" xmlns:p="http://schemas.openxmlformats.org/presentationml/2006/main">
+  <p:cSld>
+    <p:spTree>
+      <p:nvGrpSpPr>
+        <p:cNvPr id="1" name="">
+          <a:extLst>
+            <a:ext uri="{FF2B5EF4-FFF2-40B4-BE49-F238E27FC236}">
+              <a16:creationId xmlns:a16="http://schemas.microsoft.com/office/drawing/2014/main" id="{06D9A69A-38EC-086B-04D5-779145B37AA3}"/>
+            </a:ext>
+          </a:extLst>
+        </p:cNvPr>
+        <p:cNvGrpSpPr/>
+        <p:nvPr/>
+      </p:nvGrpSpPr>
+      <p:grpSpPr>
+        <a:xfrm>
+          <a:off x="0" y="0"/>
+          <a:ext cx="0" cy="0"/>
+          <a:chOff x="0" y="0"/>
+          <a:chExt cx="0" cy="0"/>
+        </a:xfrm>
+      </p:grpSpPr>
+      <p:sp>
+        <p:nvSpPr>
+          <p:cNvPr id="3" name="TextBox 2">
+            <a:extLst>
+              <a:ext uri="{FF2B5EF4-FFF2-40B4-BE49-F238E27FC236}">
+                <a16:creationId xmlns:a16="http://schemas.microsoft.com/office/drawing/2014/main" id="{FA5790C9-3C19-920A-6AF3-14562EC8FA28}"/>
+              </a:ext>
+            </a:extLst>
+          </p:cNvPr>
+          <p:cNvSpPr txBox="1"/>
+          <p:nvPr/>
+        </p:nvSpPr>
+        <p:spPr>
+          <a:xfrm>
+            <a:off x="217714" y="255046"/>
+            <a:ext cx="11756571" cy="5456750"/>
+          </a:xfrm>
+          <a:prstGeom prst="rect">
+            <a:avLst/>
+          </a:prstGeom>
+          <a:noFill/>
+        </p:spPr>
+        <p:txBody>
+          <a:bodyPr wrap="square">
+            <a:spAutoFit/>
+          </a:bodyPr>
+          <a:lstStyle/>
+          <a:p>
+            <a:pPr>
+              <a:lnSpc>
+                <a:spcPct val="150000"/>
+              </a:lnSpc>
+              <a:buNone/>
+            </a:pPr>
+            <a:r>
+              <a:rPr kumimoji="0" lang="en-US" altLang="en-US" sz="1300" b="0" i="0" u="none" strike="noStrike" cap="none" normalizeH="0" baseline="0">
+                <a:ln>
+                  <a:noFill/>
+                </a:ln>
+                <a:solidFill>
+                  <a:schemeClr val="tx1"/>
+                </a:solidFill>
+                <a:effectLst/>
+                <a:latin typeface="Arial" panose="020B0604020202020204" pitchFamily="34" charset="0"/>
+              </a:rPr>
+              <a:t>Laravel (və ümumilikdə modern PHP framework-ləri) **Dependency Injection** (qısaca DI) adlı bir dizayn prinsipindən istifadə edir.</a:t>
+            </a:r>
+            <a:endParaRPr kumimoji="0" lang="az-Latn-AZ" altLang="en-US" sz="1300" b="0" i="0" u="none" strike="noStrike" cap="none" normalizeH="0" baseline="0">
+              <a:ln>
+                <a:noFill/>
+              </a:ln>
+              <a:solidFill>
+                <a:schemeClr val="tx1"/>
+              </a:solidFill>
+              <a:effectLst/>
+              <a:latin typeface="Arial" panose="020B0604020202020204" pitchFamily="34" charset="0"/>
+            </a:endParaRPr>
+          </a:p>
+          <a:p>
+            <a:pPr>
+              <a:lnSpc>
+                <a:spcPct val="150000"/>
+              </a:lnSpc>
+              <a:buNone/>
+            </a:pPr>
+            <a:endParaRPr lang="az-Latn-AZ" altLang="en-US" sz="1300">
+              <a:latin typeface="Arial" panose="020B0604020202020204" pitchFamily="34" charset="0"/>
+            </a:endParaRPr>
+          </a:p>
+          <a:p>
+            <a:pPr>
+              <a:lnSpc>
+                <a:spcPct val="150000"/>
+              </a:lnSpc>
+              <a:buNone/>
+            </a:pPr>
+            <a:endParaRPr kumimoji="0" lang="az-Latn-AZ" altLang="en-US" sz="1300" b="0" i="0" u="none" strike="noStrike" cap="none" normalizeH="0" baseline="0">
+              <a:ln>
+                <a:noFill/>
+              </a:ln>
+              <a:solidFill>
+                <a:schemeClr val="tx1"/>
+              </a:solidFill>
+              <a:effectLst/>
+              <a:latin typeface="Arial" panose="020B0604020202020204" pitchFamily="34" charset="0"/>
+            </a:endParaRPr>
+          </a:p>
+          <a:p>
+            <a:pPr>
+              <a:lnSpc>
+                <a:spcPct val="150000"/>
+              </a:lnSpc>
+              <a:buNone/>
+            </a:pPr>
+            <a:r>
+              <a:rPr kumimoji="0" lang="en-US" altLang="en-US" sz="1300" b="1" i="0" u="none" strike="noStrike" cap="none" normalizeH="0" baseline="0">
+                <a:ln>
+                  <a:noFill/>
+                </a:ln>
+                <a:solidFill>
+                  <a:schemeClr val="tx1"/>
+                </a:solidFill>
+                <a:effectLst/>
+                <a:latin typeface="Arial" panose="020B0604020202020204" pitchFamily="34" charset="0"/>
+              </a:rPr>
+              <a:t>Dependency Injection nədir?</a:t>
+            </a:r>
+            <a:endParaRPr kumimoji="0" lang="az-Latn-AZ" altLang="en-US" sz="1300" b="1" i="0" u="none" strike="noStrike" cap="none" normalizeH="0" baseline="0">
+              <a:ln>
+                <a:noFill/>
+              </a:ln>
+              <a:solidFill>
+                <a:schemeClr val="tx1"/>
+              </a:solidFill>
+              <a:effectLst/>
+              <a:latin typeface="Arial" panose="020B0604020202020204" pitchFamily="34" charset="0"/>
+            </a:endParaRPr>
+          </a:p>
+          <a:p>
+            <a:pPr>
+              <a:lnSpc>
+                <a:spcPct val="150000"/>
+              </a:lnSpc>
+              <a:buNone/>
+            </a:pPr>
+            <a:endParaRPr kumimoji="0" lang="en-US" altLang="en-US" sz="1300" b="0" i="0" u="none" strike="noStrike" cap="none" normalizeH="0" baseline="0">
+              <a:ln>
+                <a:noFill/>
+              </a:ln>
+              <a:solidFill>
+                <a:schemeClr val="tx1"/>
+              </a:solidFill>
+              <a:effectLst/>
+              <a:latin typeface="Arial" panose="020B0604020202020204" pitchFamily="34" charset="0"/>
+            </a:endParaRPr>
+          </a:p>
+          <a:p>
+            <a:pPr>
+              <a:lnSpc>
+                <a:spcPct val="150000"/>
+              </a:lnSpc>
+              <a:buNone/>
+            </a:pPr>
+            <a:r>
+              <a:rPr kumimoji="0" lang="en-US" altLang="en-US" sz="1300" b="0" i="0" u="none" strike="noStrike" cap="none" normalizeH="0" baseline="0">
+                <a:ln>
+                  <a:noFill/>
+                </a:ln>
+                <a:solidFill>
+                  <a:schemeClr val="tx1"/>
+                </a:solidFill>
+                <a:effectLst/>
+                <a:latin typeface="Arial" panose="020B0604020202020204" pitchFamily="34" charset="0"/>
+              </a:rPr>
+              <a:t>Dependency Injection – bir obyektin ehtiyac duyduğu başqa obyektlərin</a:t>
+            </a:r>
+            <a:r>
+              <a:rPr kumimoji="0" lang="az-Latn-AZ" altLang="en-US" sz="1300" b="0" i="0" u="none" strike="noStrike" cap="none" normalizeH="0" baseline="0">
+                <a:ln>
+                  <a:noFill/>
+                </a:ln>
+                <a:solidFill>
+                  <a:schemeClr val="tx1"/>
+                </a:solidFill>
+                <a:effectLst/>
+                <a:latin typeface="Arial" panose="020B0604020202020204" pitchFamily="34" charset="0"/>
+              </a:rPr>
+              <a:t>,</a:t>
+            </a:r>
+            <a:r>
+              <a:rPr kumimoji="0" lang="en-US" altLang="en-US" sz="1300" b="0" i="0" u="none" strike="noStrike" cap="none" normalizeH="0" baseline="0">
+                <a:ln>
+                  <a:noFill/>
+                </a:ln>
+                <a:solidFill>
+                  <a:schemeClr val="tx1"/>
+                </a:solidFill>
+                <a:effectLst/>
+                <a:latin typeface="Arial" panose="020B0604020202020204" pitchFamily="34" charset="0"/>
+              </a:rPr>
+              <a:t> (asılılıqların) avtomatik şəkildə xaricdən verilməsi metodudur. Yəni, bir funksiya və ya class öz ehtiyaclarını öz içində yaratmır, əksinə kənardan ona təqdim edilir.</a:t>
+            </a:r>
+            <a:endParaRPr kumimoji="0" lang="az-Latn-AZ" altLang="en-US" sz="1300" b="0" i="0" u="none" strike="noStrike" cap="none" normalizeH="0" baseline="0">
+              <a:ln>
+                <a:noFill/>
+              </a:ln>
+              <a:solidFill>
+                <a:schemeClr val="tx1"/>
+              </a:solidFill>
+              <a:effectLst/>
+              <a:latin typeface="Arial" panose="020B0604020202020204" pitchFamily="34" charset="0"/>
+            </a:endParaRPr>
+          </a:p>
+          <a:p>
+            <a:pPr>
+              <a:lnSpc>
+                <a:spcPct val="150000"/>
+              </a:lnSpc>
+              <a:buNone/>
+            </a:pPr>
+            <a:endParaRPr lang="az-Latn-AZ" altLang="en-US" sz="1300">
+              <a:latin typeface="Arial" panose="020B0604020202020204" pitchFamily="34" charset="0"/>
+            </a:endParaRPr>
+          </a:p>
+          <a:p>
+            <a:pPr>
+              <a:lnSpc>
+                <a:spcPct val="150000"/>
+              </a:lnSpc>
+              <a:buNone/>
+            </a:pPr>
+            <a:endParaRPr kumimoji="0" lang="az-Latn-AZ" altLang="en-US" sz="1300" b="0" i="0" u="none" strike="noStrike" cap="none" normalizeH="0" baseline="0">
+              <a:ln>
+                <a:noFill/>
+              </a:ln>
+              <a:solidFill>
+                <a:schemeClr val="tx1"/>
+              </a:solidFill>
+              <a:effectLst/>
+              <a:latin typeface="Arial" panose="020B0604020202020204" pitchFamily="34" charset="0"/>
+            </a:endParaRPr>
+          </a:p>
+          <a:p>
+            <a:pPr>
+              <a:lnSpc>
+                <a:spcPct val="150000"/>
+              </a:lnSpc>
+              <a:buNone/>
+            </a:pPr>
+            <a:r>
+              <a:rPr kumimoji="0" lang="en-US" altLang="en-US" sz="1300" b="0" i="0" u="none" strike="noStrike" cap="none" normalizeH="0" baseline="0">
+                <a:ln>
+                  <a:noFill/>
+                </a:ln>
+                <a:solidFill>
+                  <a:schemeClr val="tx1"/>
+                </a:solidFill>
+                <a:effectLst/>
+                <a:latin typeface="Arial" panose="020B0604020202020204" pitchFamily="34" charset="0"/>
+              </a:rPr>
+              <a:t>Tutaq ki, bir funksiyamız Request obyektinə ehtiyac duyur. Ənənəvi üsulda belə yazıla bilərdi:</a:t>
+            </a:r>
+            <a:endParaRPr kumimoji="0" lang="az-Latn-AZ" altLang="en-US" sz="1300" b="0" i="0" u="none" strike="noStrike" cap="none" normalizeH="0" baseline="0">
+              <a:ln>
+                <a:noFill/>
+              </a:ln>
+              <a:solidFill>
+                <a:schemeClr val="tx1"/>
+              </a:solidFill>
+              <a:effectLst/>
+              <a:latin typeface="Arial" panose="020B0604020202020204" pitchFamily="34" charset="0"/>
+            </a:endParaRPr>
+          </a:p>
+          <a:p>
+            <a:pPr>
+              <a:lnSpc>
+                <a:spcPct val="150000"/>
+              </a:lnSpc>
+              <a:buNone/>
+            </a:pPr>
+            <a:endParaRPr lang="az-Latn-AZ" altLang="en-US" sz="1300">
+              <a:latin typeface="Arial" panose="020B0604020202020204" pitchFamily="34" charset="0"/>
+            </a:endParaRPr>
+          </a:p>
+          <a:p>
+            <a:pPr>
+              <a:lnSpc>
+                <a:spcPct val="150000"/>
+              </a:lnSpc>
+              <a:buNone/>
+            </a:pPr>
+            <a:endParaRPr kumimoji="0" lang="az-Latn-AZ" altLang="en-US" sz="1300" b="0" i="0" u="none" strike="noStrike" cap="none" normalizeH="0" baseline="0">
+              <a:ln>
+                <a:noFill/>
+              </a:ln>
+              <a:solidFill>
+                <a:schemeClr val="tx1"/>
+              </a:solidFill>
+              <a:effectLst/>
+              <a:latin typeface="Arial" panose="020B0604020202020204" pitchFamily="34" charset="0"/>
+            </a:endParaRPr>
+          </a:p>
+          <a:p>
+            <a:pPr>
+              <a:lnSpc>
+                <a:spcPct val="150000"/>
+              </a:lnSpc>
+              <a:buNone/>
+            </a:pPr>
+            <a:endParaRPr lang="az-Latn-AZ" altLang="en-US" sz="1300">
+              <a:latin typeface="Arial" panose="020B0604020202020204" pitchFamily="34" charset="0"/>
+            </a:endParaRPr>
+          </a:p>
+          <a:p>
+            <a:pPr>
+              <a:lnSpc>
+                <a:spcPct val="150000"/>
+              </a:lnSpc>
+              <a:buNone/>
+            </a:pPr>
+            <a:endParaRPr kumimoji="0" lang="az-Latn-AZ" altLang="en-US" sz="1300" b="0" i="0" u="none" strike="noStrike" cap="none" normalizeH="0" baseline="0">
+              <a:ln>
+                <a:noFill/>
+              </a:ln>
+              <a:solidFill>
+                <a:schemeClr val="tx1"/>
+              </a:solidFill>
+              <a:effectLst/>
+              <a:latin typeface="Arial" panose="020B0604020202020204" pitchFamily="34" charset="0"/>
+            </a:endParaRPr>
+          </a:p>
+          <a:p>
+            <a:pPr>
+              <a:lnSpc>
+                <a:spcPct val="150000"/>
+              </a:lnSpc>
+              <a:buNone/>
+            </a:pPr>
+            <a:endParaRPr lang="az-Latn-AZ" altLang="en-US" sz="1300">
+              <a:latin typeface="Arial" panose="020B0604020202020204" pitchFamily="34" charset="0"/>
+            </a:endParaRPr>
+          </a:p>
+          <a:p>
+            <a:pPr>
+              <a:lnSpc>
+                <a:spcPct val="150000"/>
+              </a:lnSpc>
+              <a:buNone/>
+            </a:pPr>
+            <a:endParaRPr kumimoji="0" lang="az-Latn-AZ" altLang="en-US" sz="1300" b="0" i="0" u="none" strike="noStrike" cap="none" normalizeH="0" baseline="0">
+              <a:ln>
+                <a:noFill/>
+              </a:ln>
+              <a:solidFill>
+                <a:schemeClr val="tx1"/>
+              </a:solidFill>
+              <a:effectLst/>
+              <a:latin typeface="Arial" panose="020B0604020202020204" pitchFamily="34" charset="0"/>
+            </a:endParaRPr>
+          </a:p>
+          <a:p>
+            <a:pPr>
+              <a:lnSpc>
+                <a:spcPct val="150000"/>
+              </a:lnSpc>
+              <a:buNone/>
+            </a:pPr>
+            <a:r>
+              <a:rPr kumimoji="0" lang="en-US" altLang="en-US" sz="1300" b="0" i="0" u="none" strike="noStrike" cap="none" normalizeH="0" baseline="0">
+                <a:ln>
+                  <a:noFill/>
+                </a:ln>
+                <a:solidFill>
+                  <a:schemeClr val="tx1"/>
+                </a:solidFill>
+                <a:effectLst/>
+                <a:latin typeface="Arial" panose="020B0604020202020204" pitchFamily="34" charset="0"/>
+              </a:rPr>
+              <a:t>Bu isə "</a:t>
+            </a:r>
+            <a:r>
+              <a:rPr kumimoji="0" lang="en-US" altLang="en-US" sz="1300" b="1" i="0" u="none" strike="noStrike" cap="none" normalizeH="0" baseline="0">
+                <a:ln>
+                  <a:noFill/>
+                </a:ln>
+                <a:solidFill>
+                  <a:srgbClr val="00B050"/>
+                </a:solidFill>
+                <a:effectLst/>
+                <a:latin typeface="Arial" panose="020B0604020202020204" pitchFamily="34" charset="0"/>
+              </a:rPr>
+              <a:t>tight coupling</a:t>
+            </a:r>
+            <a:r>
+              <a:rPr kumimoji="0" lang="en-US" altLang="en-US" sz="1300" b="0" i="0" u="none" strike="noStrike" cap="none" normalizeH="0" baseline="0">
+                <a:ln>
+                  <a:noFill/>
+                </a:ln>
+                <a:solidFill>
+                  <a:schemeClr val="tx1"/>
+                </a:solidFill>
+                <a:effectLst/>
+                <a:latin typeface="Arial" panose="020B0604020202020204" pitchFamily="34" charset="0"/>
+              </a:rPr>
+              <a:t>" (sıx bağlılıq) yaradır. Bu dizaynda </a:t>
+            </a:r>
+            <a:r>
+              <a:rPr kumimoji="0" lang="en-US" altLang="en-US" sz="1300" b="1" i="0" u="none" strike="noStrike" cap="none" normalizeH="0" baseline="0">
+                <a:ln>
+                  <a:noFill/>
+                </a:ln>
+                <a:solidFill>
+                  <a:schemeClr val="tx1"/>
+                </a:solidFill>
+                <a:effectLst/>
+                <a:latin typeface="Arial" panose="020B0604020202020204" pitchFamily="34" charset="0"/>
+              </a:rPr>
+              <a:t>getSessionData() </a:t>
+            </a:r>
+            <a:r>
+              <a:rPr kumimoji="0" lang="en-US" altLang="en-US" sz="1300" b="0" i="0" u="none" strike="noStrike" cap="none" normalizeH="0" baseline="0">
+                <a:ln>
+                  <a:noFill/>
+                </a:ln>
+                <a:solidFill>
+                  <a:schemeClr val="tx1"/>
+                </a:solidFill>
+                <a:effectLst/>
+                <a:latin typeface="Arial" panose="020B0604020202020204" pitchFamily="34" charset="0"/>
+              </a:rPr>
+              <a:t>funksiyası yalnız </a:t>
+            </a:r>
+            <a:r>
+              <a:rPr kumimoji="0" lang="en-US" altLang="en-US" sz="1300" b="1" i="0" u="none" strike="noStrike" cap="none" normalizeH="0" baseline="0">
+                <a:ln>
+                  <a:noFill/>
+                </a:ln>
+                <a:solidFill>
+                  <a:schemeClr val="tx1"/>
+                </a:solidFill>
+                <a:effectLst/>
+                <a:latin typeface="Arial" panose="020B0604020202020204" pitchFamily="34" charset="0"/>
+              </a:rPr>
+              <a:t>Request</a:t>
+            </a:r>
+            <a:r>
+              <a:rPr kumimoji="0" lang="en-US" altLang="en-US" sz="1300" b="0" i="0" u="none" strike="noStrike" cap="none" normalizeH="0" baseline="0">
+                <a:ln>
+                  <a:noFill/>
+                </a:ln>
+                <a:solidFill>
+                  <a:schemeClr val="tx1"/>
+                </a:solidFill>
+                <a:effectLst/>
+                <a:latin typeface="Arial" panose="020B0604020202020204" pitchFamily="34" charset="0"/>
+              </a:rPr>
+              <a:t> obyekti ilə işləyir və onu dəyişmək, test etmək çətin olur.</a:t>
+            </a:r>
+          </a:p>
+        </p:txBody>
+      </p:sp>
+      <p:pic>
+        <p:nvPicPr>
+          <p:cNvPr id="4" name="Picture 3">
+            <a:extLst>
+              <a:ext uri="{FF2B5EF4-FFF2-40B4-BE49-F238E27FC236}">
+                <a16:creationId xmlns:a16="http://schemas.microsoft.com/office/drawing/2014/main" id="{2CCF51B6-8C95-8716-3CA3-454FCE6538FD}"/>
+              </a:ext>
+            </a:extLst>
+          </p:cNvPr>
+          <p:cNvPicPr>
+            <a:picLocks noChangeAspect="1"/>
+          </p:cNvPicPr>
+          <p:nvPr/>
+        </p:nvPicPr>
+        <p:blipFill>
+          <a:blip r:embed="rId2"/>
+          <a:stretch>
+            <a:fillRect/>
+          </a:stretch>
+        </p:blipFill>
+        <p:spPr>
+          <a:xfrm>
+            <a:off x="217714" y="3568046"/>
+            <a:ext cx="3743847" cy="1190791"/>
+          </a:xfrm>
+          <a:prstGeom prst="rect">
+            <a:avLst/>
+          </a:prstGeom>
+        </p:spPr>
+      </p:pic>
+    </p:spTree>
+    <p:extLst>
+      <p:ext uri="{BB962C8B-B14F-4D97-AF65-F5344CB8AC3E}">
+        <p14:creationId xmlns:p14="http://schemas.microsoft.com/office/powerpoint/2010/main" val="3798058766"/>
+      </p:ext>
+    </p:extLst>
+  </p:cSld>
+  <p:clrMapOvr>
+    <a:masterClrMapping/>
+  </p:clrMapOvr>
+</p:sld>
+</file>
+
+<file path=ppt/slides/slide6.xml><?xml version="1.0" encoding="utf-8"?>
+<p:sld xmlns:a="http://schemas.openxmlformats.org/drawingml/2006/main" xmlns:r="http://schemas.openxmlformats.org/officeDocument/2006/relationships" xmlns:p="http://schemas.openxmlformats.org/presentationml/2006/main">
+  <p:cSld>
+    <p:spTree>
+      <p:nvGrpSpPr>
+        <p:cNvPr id="1" name="">
+          <a:extLst>
+            <a:ext uri="{FF2B5EF4-FFF2-40B4-BE49-F238E27FC236}">
+              <a16:creationId xmlns:a16="http://schemas.microsoft.com/office/drawing/2014/main" id="{E1A23529-827C-D8C6-397E-BBF0EC6153B1}"/>
+            </a:ext>
+          </a:extLst>
+        </p:cNvPr>
+        <p:cNvGrpSpPr/>
+        <p:nvPr/>
+      </p:nvGrpSpPr>
+      <p:grpSpPr>
+        <a:xfrm>
+          <a:off x="0" y="0"/>
+          <a:ext cx="0" cy="0"/>
+          <a:chOff x="0" y="0"/>
+          <a:chExt cx="0" cy="0"/>
+        </a:xfrm>
+      </p:grpSpPr>
+      <p:sp>
+        <p:nvSpPr>
+          <p:cNvPr id="3" name="TextBox 2">
+            <a:extLst>
+              <a:ext uri="{FF2B5EF4-FFF2-40B4-BE49-F238E27FC236}">
+                <a16:creationId xmlns:a16="http://schemas.microsoft.com/office/drawing/2014/main" id="{0B0AF9A0-0EBF-BE61-FA13-0A5D43F35F7C}"/>
+              </a:ext>
+            </a:extLst>
+          </p:cNvPr>
+          <p:cNvSpPr txBox="1"/>
+          <p:nvPr/>
+        </p:nvSpPr>
+        <p:spPr>
+          <a:xfrm>
+            <a:off x="217714" y="255046"/>
+            <a:ext cx="11756571" cy="5756832"/>
+          </a:xfrm>
+          <a:prstGeom prst="rect">
+            <a:avLst/>
+          </a:prstGeom>
+          <a:noFill/>
+        </p:spPr>
+        <p:txBody>
+          <a:bodyPr wrap="square">
+            <a:spAutoFit/>
+          </a:bodyPr>
+          <a:lstStyle/>
+          <a:p>
+            <a:pPr>
+              <a:lnSpc>
+                <a:spcPct val="150000"/>
+              </a:lnSpc>
+              <a:buNone/>
+            </a:pPr>
+            <a:r>
+              <a:rPr kumimoji="0" lang="en-US" altLang="en-US" sz="1300" b="0" i="0" u="none" strike="noStrike" cap="none" normalizeH="0" baseline="0">
+                <a:ln>
+                  <a:noFill/>
+                </a:ln>
+                <a:solidFill>
+                  <a:schemeClr val="tx1"/>
+                </a:solidFill>
+                <a:effectLst/>
+                <a:latin typeface="Arial" panose="020B0604020202020204" pitchFamily="34" charset="0"/>
+              </a:rPr>
+              <a:t>Amma Laravel bunu automatik şəkildə edir. Məsələn:</a:t>
+            </a:r>
+            <a:endParaRPr kumimoji="0" lang="az-Latn-AZ" altLang="en-US" sz="1300" b="0" i="0" u="none" strike="noStrike" cap="none" normalizeH="0" baseline="0">
+              <a:ln>
+                <a:noFill/>
+              </a:ln>
+              <a:solidFill>
+                <a:schemeClr val="tx1"/>
+              </a:solidFill>
+              <a:effectLst/>
+              <a:latin typeface="Arial" panose="020B0604020202020204" pitchFamily="34" charset="0"/>
+            </a:endParaRPr>
+          </a:p>
+          <a:p>
+            <a:pPr>
+              <a:lnSpc>
+                <a:spcPct val="150000"/>
+              </a:lnSpc>
+              <a:buNone/>
+            </a:pPr>
+            <a:endParaRPr lang="az-Latn-AZ" altLang="en-US" sz="1300">
+              <a:latin typeface="Arial" panose="020B0604020202020204" pitchFamily="34" charset="0"/>
+            </a:endParaRPr>
+          </a:p>
+          <a:p>
+            <a:pPr>
+              <a:lnSpc>
+                <a:spcPct val="150000"/>
+              </a:lnSpc>
+              <a:buNone/>
+            </a:pPr>
+            <a:endParaRPr kumimoji="0" lang="az-Latn-AZ" altLang="en-US" sz="1300" b="0" i="0" u="none" strike="noStrike" cap="none" normalizeH="0" baseline="0">
+              <a:ln>
+                <a:noFill/>
+              </a:ln>
+              <a:solidFill>
+                <a:schemeClr val="tx1"/>
+              </a:solidFill>
+              <a:effectLst/>
+              <a:latin typeface="Arial" panose="020B0604020202020204" pitchFamily="34" charset="0"/>
+            </a:endParaRPr>
+          </a:p>
+          <a:p>
+            <a:pPr>
+              <a:lnSpc>
+                <a:spcPct val="150000"/>
+              </a:lnSpc>
+              <a:buNone/>
+            </a:pPr>
+            <a:endParaRPr lang="az-Latn-AZ" altLang="en-US" sz="1300">
+              <a:latin typeface="Arial" panose="020B0604020202020204" pitchFamily="34" charset="0"/>
+            </a:endParaRPr>
+          </a:p>
+          <a:p>
+            <a:pPr>
+              <a:lnSpc>
+                <a:spcPct val="150000"/>
+              </a:lnSpc>
+              <a:buNone/>
+            </a:pPr>
+            <a:endParaRPr kumimoji="0" lang="az-Latn-AZ" altLang="en-US" sz="1300" b="0" i="0" u="none" strike="noStrike" cap="none" normalizeH="0" baseline="0">
+              <a:ln>
+                <a:noFill/>
+              </a:ln>
+              <a:solidFill>
+                <a:schemeClr val="tx1"/>
+              </a:solidFill>
+              <a:effectLst/>
+              <a:latin typeface="Arial" panose="020B0604020202020204" pitchFamily="34" charset="0"/>
+            </a:endParaRPr>
+          </a:p>
+          <a:p>
+            <a:pPr>
+              <a:lnSpc>
+                <a:spcPct val="150000"/>
+              </a:lnSpc>
+              <a:buNone/>
+            </a:pPr>
+            <a:endParaRPr lang="az-Latn-AZ" altLang="en-US" sz="1300">
+              <a:latin typeface="Arial" panose="020B0604020202020204" pitchFamily="34" charset="0"/>
+            </a:endParaRPr>
+          </a:p>
+          <a:p>
+            <a:pPr>
+              <a:lnSpc>
+                <a:spcPct val="150000"/>
+              </a:lnSpc>
+              <a:buNone/>
+            </a:pPr>
+            <a:endParaRPr kumimoji="0" lang="az-Latn-AZ" altLang="en-US" sz="1300" b="0" i="0" u="none" strike="noStrike" cap="none" normalizeH="0" baseline="0">
+              <a:ln>
+                <a:noFill/>
+              </a:ln>
+              <a:solidFill>
+                <a:schemeClr val="tx1"/>
+              </a:solidFill>
+              <a:effectLst/>
+              <a:latin typeface="Arial" panose="020B0604020202020204" pitchFamily="34" charset="0"/>
+            </a:endParaRPr>
+          </a:p>
+          <a:p>
+            <a:pPr>
+              <a:lnSpc>
+                <a:spcPct val="150000"/>
+              </a:lnSpc>
+              <a:buNone/>
+            </a:pPr>
+            <a:endParaRPr lang="az-Latn-AZ" altLang="en-US" sz="1300">
+              <a:latin typeface="Arial" panose="020B0604020202020204" pitchFamily="34" charset="0"/>
+            </a:endParaRPr>
+          </a:p>
+          <a:p>
+            <a:pPr>
+              <a:lnSpc>
+                <a:spcPct val="150000"/>
+              </a:lnSpc>
+              <a:buNone/>
+            </a:pPr>
+            <a:endParaRPr kumimoji="0" lang="az-Latn-AZ" altLang="en-US" sz="1300" b="0" i="0" u="none" strike="noStrike" cap="none" normalizeH="0" baseline="0">
+              <a:ln>
+                <a:noFill/>
+              </a:ln>
+              <a:solidFill>
+                <a:schemeClr val="tx1"/>
+              </a:solidFill>
+              <a:effectLst/>
+              <a:latin typeface="Arial" panose="020B0604020202020204" pitchFamily="34" charset="0"/>
+            </a:endParaRPr>
+          </a:p>
+          <a:p>
+            <a:pPr>
+              <a:lnSpc>
+                <a:spcPct val="150000"/>
+              </a:lnSpc>
+              <a:buNone/>
+            </a:pPr>
+            <a:endParaRPr lang="az-Latn-AZ" altLang="en-US" sz="1300">
+              <a:latin typeface="Arial" panose="020B0604020202020204" pitchFamily="34" charset="0"/>
+            </a:endParaRPr>
+          </a:p>
+          <a:p>
+            <a:pPr>
+              <a:lnSpc>
+                <a:spcPct val="150000"/>
+              </a:lnSpc>
+              <a:buNone/>
+            </a:pPr>
+            <a:r>
+              <a:rPr kumimoji="0" lang="en-US" altLang="en-US" sz="1300" b="0" i="0" u="none" strike="noStrike" cap="none" normalizeH="0" baseline="0">
+                <a:ln>
+                  <a:noFill/>
+                </a:ln>
+                <a:solidFill>
+                  <a:schemeClr val="tx1"/>
+                </a:solidFill>
+                <a:effectLst/>
+                <a:latin typeface="Arial" panose="020B0604020202020204" pitchFamily="34" charset="0"/>
+              </a:rPr>
+              <a:t>Laravel burada </a:t>
+            </a:r>
+            <a:r>
+              <a:rPr kumimoji="0" lang="en-US" altLang="en-US" sz="1300" b="1" i="0" u="none" strike="noStrike" cap="none" normalizeH="0" baseline="0">
+                <a:ln>
+                  <a:noFill/>
+                </a:ln>
+                <a:solidFill>
+                  <a:schemeClr val="tx1"/>
+                </a:solidFill>
+                <a:effectLst/>
+                <a:latin typeface="Arial" panose="020B0604020202020204" pitchFamily="34" charset="0"/>
+              </a:rPr>
+              <a:t>Request</a:t>
+            </a:r>
+            <a:r>
+              <a:rPr kumimoji="0" lang="en-US" altLang="en-US" sz="1300" b="0" i="0" u="none" strike="noStrike" cap="none" normalizeH="0" baseline="0">
+                <a:ln>
+                  <a:noFill/>
+                </a:ln>
+                <a:solidFill>
+                  <a:schemeClr val="tx1"/>
+                </a:solidFill>
+                <a:effectLst/>
+                <a:latin typeface="Arial" panose="020B0604020202020204" pitchFamily="34" charset="0"/>
+              </a:rPr>
+              <a:t> obyektini özündə "</a:t>
+            </a:r>
+            <a:r>
+              <a:rPr kumimoji="0" lang="en-US" altLang="en-US" sz="1300" b="1" i="0" u="none" strike="noStrike" cap="none" normalizeH="0" baseline="0">
+                <a:ln>
+                  <a:noFill/>
+                </a:ln>
+                <a:solidFill>
+                  <a:schemeClr val="tx1"/>
+                </a:solidFill>
+                <a:effectLst/>
+                <a:latin typeface="Arial" panose="020B0604020202020204" pitchFamily="34" charset="0"/>
+              </a:rPr>
+              <a:t>inject</a:t>
+            </a:r>
+            <a:r>
+              <a:rPr kumimoji="0" lang="en-US" altLang="en-US" sz="1300" b="0" i="0" u="none" strike="noStrike" cap="none" normalizeH="0" baseline="0">
+                <a:ln>
+                  <a:noFill/>
+                </a:ln>
+                <a:solidFill>
+                  <a:schemeClr val="tx1"/>
+                </a:solidFill>
+                <a:effectLst/>
+                <a:latin typeface="Arial" panose="020B0604020202020204" pitchFamily="34" charset="0"/>
+              </a:rPr>
+              <a:t>" (yerləşdirir). Sən onu </a:t>
+            </a:r>
+            <a:r>
+              <a:rPr kumimoji="0" lang="en-US" altLang="en-US" sz="1300" b="1" i="0" u="none" strike="noStrike" cap="none" normalizeH="0" baseline="0">
+                <a:ln>
+                  <a:noFill/>
+                </a:ln>
+                <a:solidFill>
+                  <a:srgbClr val="00B050"/>
+                </a:solidFill>
+                <a:effectLst/>
+                <a:latin typeface="Arial" panose="020B0604020202020204" pitchFamily="34" charset="0"/>
+              </a:rPr>
+              <a:t>new</a:t>
+            </a:r>
+            <a:r>
+              <a:rPr kumimoji="0" lang="en-US" altLang="en-US" sz="1300" b="0" i="0" u="none" strike="noStrike" cap="none" normalizeH="0" baseline="0">
+                <a:ln>
+                  <a:noFill/>
+                </a:ln>
+                <a:solidFill>
+                  <a:schemeClr val="tx1"/>
+                </a:solidFill>
+                <a:effectLst/>
+                <a:latin typeface="Arial" panose="020B0604020202020204" pitchFamily="34" charset="0"/>
+              </a:rPr>
+              <a:t> ilə yaratmırsan. Laravel avtomatik olaraq bu funksiyanın parametrindən anlayır ki, </a:t>
+            </a:r>
+            <a:r>
+              <a:rPr kumimoji="0" lang="en-US" altLang="en-US" sz="1300" b="1" u="none" strike="noStrike" cap="none" normalizeH="0" baseline="0">
+                <a:ln>
+                  <a:noFill/>
+                </a:ln>
+                <a:solidFill>
+                  <a:schemeClr val="tx1"/>
+                </a:solidFill>
+                <a:effectLst/>
+                <a:latin typeface="Arial" panose="020B0604020202020204" pitchFamily="34" charset="0"/>
+              </a:rPr>
+              <a:t>Request</a:t>
+            </a:r>
+            <a:r>
+              <a:rPr kumimoji="0" lang="en-US" altLang="en-US" sz="1300" b="0" i="0" u="none" strike="noStrike" cap="none" normalizeH="0" baseline="0">
+                <a:ln>
+                  <a:noFill/>
+                </a:ln>
+                <a:solidFill>
+                  <a:schemeClr val="tx1"/>
+                </a:solidFill>
+                <a:effectLst/>
+                <a:latin typeface="Arial" panose="020B0604020202020204" pitchFamily="34" charset="0"/>
+              </a:rPr>
+              <a:t> obyektinə ehtiyac var və onu kənardan verir. Bu </a:t>
+            </a:r>
+            <a:r>
+              <a:rPr kumimoji="0" lang="en-US" altLang="en-US" sz="1300" b="1" i="0" u="none" strike="noStrike" cap="none" normalizeH="0" baseline="0">
+                <a:ln>
+                  <a:noFill/>
+                </a:ln>
+                <a:solidFill>
+                  <a:schemeClr val="tx1"/>
+                </a:solidFill>
+                <a:effectLst/>
+                <a:latin typeface="Arial" panose="020B0604020202020204" pitchFamily="34" charset="0"/>
+              </a:rPr>
+              <a:t>dependency injection </a:t>
+            </a:r>
+            <a:r>
+              <a:rPr kumimoji="0" lang="en-US" altLang="en-US" sz="1300" b="0" i="0" u="none" strike="noStrike" cap="none" normalizeH="0" baseline="0">
+                <a:ln>
+                  <a:noFill/>
+                </a:ln>
+                <a:solidFill>
+                  <a:schemeClr val="tx1"/>
+                </a:solidFill>
+                <a:effectLst/>
+                <a:latin typeface="Arial" panose="020B0604020202020204" pitchFamily="34" charset="0"/>
+              </a:rPr>
+              <a:t>prinsipidir.</a:t>
+            </a:r>
+            <a:endParaRPr kumimoji="0" lang="az-Latn-AZ" altLang="en-US" sz="1300" b="0" i="0" u="none" strike="noStrike" cap="none" normalizeH="0" baseline="0">
+              <a:ln>
+                <a:noFill/>
+              </a:ln>
+              <a:solidFill>
+                <a:schemeClr val="tx1"/>
+              </a:solidFill>
+              <a:effectLst/>
+              <a:latin typeface="Arial" panose="020B0604020202020204" pitchFamily="34" charset="0"/>
+            </a:endParaRPr>
+          </a:p>
+          <a:p>
+            <a:pPr>
+              <a:lnSpc>
+                <a:spcPct val="150000"/>
+              </a:lnSpc>
+              <a:buNone/>
+            </a:pPr>
+            <a:endParaRPr lang="az-Latn-AZ" altLang="en-US" sz="1300">
+              <a:latin typeface="Arial" panose="020B0604020202020204" pitchFamily="34" charset="0"/>
+            </a:endParaRPr>
+          </a:p>
+          <a:p>
+            <a:pPr>
+              <a:lnSpc>
+                <a:spcPct val="150000"/>
+              </a:lnSpc>
+              <a:buNone/>
+            </a:pPr>
+            <a:endParaRPr kumimoji="0" lang="az-Latn-AZ" altLang="en-US" sz="1300" b="0" i="0" u="none" strike="noStrike" cap="none" normalizeH="0" baseline="0">
+              <a:ln>
+                <a:noFill/>
+              </a:ln>
+              <a:solidFill>
+                <a:schemeClr val="tx1"/>
+              </a:solidFill>
+              <a:effectLst/>
+              <a:latin typeface="Arial" panose="020B0604020202020204" pitchFamily="34" charset="0"/>
+            </a:endParaRPr>
+          </a:p>
+          <a:p>
+            <a:pPr>
+              <a:lnSpc>
+                <a:spcPct val="150000"/>
+              </a:lnSpc>
+              <a:buNone/>
+            </a:pPr>
+            <a:endParaRPr lang="az-Latn-AZ" altLang="en-US" sz="1300">
+              <a:latin typeface="Arial" panose="020B0604020202020204" pitchFamily="34" charset="0"/>
+            </a:endParaRPr>
+          </a:p>
+          <a:p>
+            <a:pPr>
+              <a:lnSpc>
+                <a:spcPct val="150000"/>
+              </a:lnSpc>
+              <a:buNone/>
+            </a:pPr>
+            <a:endParaRPr kumimoji="0" lang="az-Latn-AZ" altLang="en-US" sz="1300" b="0" i="0" u="none" strike="noStrike" cap="none" normalizeH="0" baseline="0">
+              <a:ln>
+                <a:noFill/>
+              </a:ln>
+              <a:solidFill>
+                <a:schemeClr val="tx1"/>
+              </a:solidFill>
+              <a:effectLst/>
+              <a:latin typeface="Arial" panose="020B0604020202020204" pitchFamily="34" charset="0"/>
+            </a:endParaRPr>
+          </a:p>
+          <a:p>
+            <a:pPr>
+              <a:lnSpc>
+                <a:spcPct val="150000"/>
+              </a:lnSpc>
+              <a:buNone/>
+            </a:pPr>
+            <a:r>
+              <a:rPr kumimoji="0" lang="az-Latn-AZ" altLang="en-US" sz="1300" b="1" i="0" u="none" strike="noStrike" cap="none" normalizeH="0" baseline="0">
+                <a:ln>
+                  <a:noFill/>
+                </a:ln>
+                <a:solidFill>
+                  <a:schemeClr val="tx1"/>
+                </a:solidFill>
+                <a:effectLst/>
+                <a:latin typeface="Arial" panose="020B0604020202020204" pitchFamily="34" charset="0"/>
+              </a:rPr>
+              <a:t>Q</a:t>
+            </a:r>
+            <a:r>
+              <a:rPr kumimoji="0" lang="en-US" altLang="en-US" sz="1300" b="1" i="0" u="none" strike="noStrike" cap="none" normalizeH="0" baseline="0">
+                <a:ln>
+                  <a:noFill/>
+                </a:ln>
+                <a:solidFill>
+                  <a:schemeClr val="tx1"/>
+                </a:solidFill>
+                <a:effectLst/>
+                <a:latin typeface="Arial" panose="020B0604020202020204" pitchFamily="34" charset="0"/>
+              </a:rPr>
+              <a:t>ısa Cümlə ilə Yekun</a:t>
+            </a:r>
+            <a:r>
+              <a:rPr kumimoji="0" lang="en-US" altLang="en-US" sz="1300" b="0" i="0" u="none" strike="noStrike" cap="none" normalizeH="0" baseline="0">
+                <a:ln>
+                  <a:noFill/>
+                </a:ln>
+                <a:solidFill>
+                  <a:schemeClr val="tx1"/>
+                </a:solidFill>
+                <a:effectLst/>
+                <a:latin typeface="Arial" panose="020B0604020202020204" pitchFamily="34" charset="0"/>
+              </a:rPr>
+              <a:t>: </a:t>
+            </a:r>
+            <a:endParaRPr kumimoji="0" lang="az-Latn-AZ" altLang="en-US" sz="1300" b="0" i="0" u="none" strike="noStrike" cap="none" normalizeH="0" baseline="0">
+              <a:ln>
+                <a:noFill/>
+              </a:ln>
+              <a:solidFill>
+                <a:schemeClr val="tx1"/>
+              </a:solidFill>
+              <a:effectLst/>
+              <a:latin typeface="Arial" panose="020B0604020202020204" pitchFamily="34" charset="0"/>
+            </a:endParaRPr>
+          </a:p>
+          <a:p>
+            <a:pPr marL="742950" lvl="1" indent="-285750">
+              <a:lnSpc>
+                <a:spcPct val="150000"/>
+              </a:lnSpc>
+              <a:buFont typeface="Arial" panose="020B0604020202020204" pitchFamily="34" charset="0"/>
+              <a:buChar char="•"/>
+            </a:pPr>
+            <a:r>
+              <a:rPr kumimoji="0" lang="en-US" altLang="en-US" sz="1300" b="1" i="0" u="none" strike="noStrike" cap="none" normalizeH="0" baseline="0">
+                <a:ln>
+                  <a:noFill/>
+                </a:ln>
+                <a:solidFill>
+                  <a:srgbClr val="FF0000"/>
+                </a:solidFill>
+                <a:effectLst/>
+                <a:latin typeface="Arial" panose="020B0604020202020204" pitchFamily="34" charset="0"/>
+              </a:rPr>
+              <a:t>Dependency Injection </a:t>
+            </a:r>
+            <a:r>
+              <a:rPr kumimoji="0" lang="en-US" altLang="en-US" sz="1300" b="0" i="0" u="none" strike="noStrike" cap="none" normalizeH="0" baseline="0">
+                <a:ln>
+                  <a:noFill/>
+                </a:ln>
+                <a:solidFill>
+                  <a:schemeClr val="tx1"/>
+                </a:solidFill>
+                <a:effectLst/>
+                <a:latin typeface="Arial" panose="020B0604020202020204" pitchFamily="34" charset="0"/>
+              </a:rPr>
+              <a:t>– bu, Laravel-in bir funksiya və ya class üçün lazım olan obyektləri avtomatik şəkildə təqdim etməsidir, sən onu özün new ilə yaratmırsan.</a:t>
+            </a:r>
+          </a:p>
+        </p:txBody>
+      </p:sp>
+      <p:pic>
+        <p:nvPicPr>
+          <p:cNvPr id="4" name="Picture 3">
+            <a:extLst>
+              <a:ext uri="{FF2B5EF4-FFF2-40B4-BE49-F238E27FC236}">
+                <a16:creationId xmlns:a16="http://schemas.microsoft.com/office/drawing/2014/main" id="{5D848E35-C951-1F11-35C4-7F062ED523D5}"/>
+              </a:ext>
+            </a:extLst>
+          </p:cNvPr>
+          <p:cNvPicPr>
+            <a:picLocks noChangeAspect="1"/>
+          </p:cNvPicPr>
+          <p:nvPr/>
+        </p:nvPicPr>
+        <p:blipFill>
+          <a:blip r:embed="rId2"/>
+          <a:stretch>
+            <a:fillRect/>
+          </a:stretch>
+        </p:blipFill>
+        <p:spPr>
+          <a:xfrm>
+            <a:off x="217714" y="841861"/>
+            <a:ext cx="4401164" cy="1705213"/>
+          </a:xfrm>
+          <a:prstGeom prst="rect">
+            <a:avLst/>
+          </a:prstGeom>
+        </p:spPr>
+      </p:pic>
+    </p:spTree>
+    <p:extLst>
+      <p:ext uri="{BB962C8B-B14F-4D97-AF65-F5344CB8AC3E}">
+        <p14:creationId xmlns:p14="http://schemas.microsoft.com/office/powerpoint/2010/main" val="1675387076"/>
+      </p:ext>
+    </p:extLst>
+  </p:cSld>
+  <p:clrMapOvr>
+    <a:masterClrMapping/>
+  </p:clrMapOvr>
+</p:sld>
+</file>
+
+<file path=ppt/slides/slide7.xml><?xml version="1.0" encoding="utf-8"?>
+<p:sld xmlns:a="http://schemas.openxmlformats.org/drawingml/2006/main" xmlns:r="http://schemas.openxmlformats.org/officeDocument/2006/relationships" xmlns:p="http://schemas.openxmlformats.org/presentationml/2006/main">
+  <p:cSld>
+    <p:spTree>
+      <p:nvGrpSpPr>
+        <p:cNvPr id="1" name="">
+          <a:extLst>
+            <a:ext uri="{FF2B5EF4-FFF2-40B4-BE49-F238E27FC236}">
+              <a16:creationId xmlns:a16="http://schemas.microsoft.com/office/drawing/2014/main" id="{B83BE019-05D8-3CF9-2F37-C79AB62805C3}"/>
+            </a:ext>
+          </a:extLst>
+        </p:cNvPr>
+        <p:cNvGrpSpPr/>
+        <p:nvPr/>
+      </p:nvGrpSpPr>
+      <p:grpSpPr>
+        <a:xfrm>
+          <a:off x="0" y="0"/>
+          <a:ext cx="0" cy="0"/>
+          <a:chOff x="0" y="0"/>
+          <a:chExt cx="0" cy="0"/>
+        </a:xfrm>
+      </p:grpSpPr>
+      <p:sp>
+        <p:nvSpPr>
+          <p:cNvPr id="3" name="TextBox 2">
+            <a:extLst>
+              <a:ext uri="{FF2B5EF4-FFF2-40B4-BE49-F238E27FC236}">
+                <a16:creationId xmlns:a16="http://schemas.microsoft.com/office/drawing/2014/main" id="{5304EE26-B709-88D5-1D2D-0F7D19072F06}"/>
+              </a:ext>
+            </a:extLst>
+          </p:cNvPr>
+          <p:cNvSpPr txBox="1"/>
+          <p:nvPr/>
+        </p:nvSpPr>
+        <p:spPr>
+          <a:xfrm>
+            <a:off x="217714" y="255046"/>
+            <a:ext cx="11756571" cy="355354"/>
+          </a:xfrm>
+          <a:prstGeom prst="rect">
+            <a:avLst/>
+          </a:prstGeom>
+          <a:noFill/>
+        </p:spPr>
+        <p:txBody>
+          <a:bodyPr wrap="square">
+            <a:spAutoFit/>
+          </a:bodyPr>
+          <a:lstStyle/>
+          <a:p>
+            <a:pPr>
+              <a:lnSpc>
+                <a:spcPct val="150000"/>
+              </a:lnSpc>
+              <a:buNone/>
+            </a:pPr>
+            <a:r>
+              <a:rPr kumimoji="0" lang="en-US" altLang="en-US" sz="1300" b="0" i="0" u="none" strike="noStrike" cap="none" normalizeH="0" baseline="0">
+                <a:ln>
+                  <a:noFill/>
+                </a:ln>
+                <a:solidFill>
+                  <a:schemeClr val="tx1"/>
+                </a:solidFill>
+                <a:effectLst/>
+                <a:latin typeface="Arial" panose="020B0604020202020204" pitchFamily="34" charset="0"/>
+              </a:rPr>
+              <a:t>.</a:t>
+            </a:r>
+          </a:p>
+        </p:txBody>
+      </p:sp>
+    </p:spTree>
+    <p:extLst>
+      <p:ext uri="{BB962C8B-B14F-4D97-AF65-F5344CB8AC3E}">
+        <p14:creationId xmlns:p14="http://schemas.microsoft.com/office/powerpoint/2010/main" val="2196394760"/>
+      </p:ext>
+    </p:extLst>
+  </p:cSld>
+  <p:clrMapOvr>
+    <a:masterClrMapping/>
+  </p:clrMapOvr>
+</p:sld>
+</file>
+
+<file path=ppt/slides/slide8.xml><?xml version="1.0" encoding="utf-8"?>
+<p:sld xmlns:a="http://schemas.openxmlformats.org/drawingml/2006/main" xmlns:r="http://schemas.openxmlformats.org/officeDocument/2006/relationships" xmlns:p="http://schemas.openxmlformats.org/presentationml/2006/main">
+  <p:cSld>
+    <p:spTree>
+      <p:nvGrpSpPr>
+        <p:cNvPr id="1" name="">
+          <a:extLst>
+            <a:ext uri="{FF2B5EF4-FFF2-40B4-BE49-F238E27FC236}">
+              <a16:creationId xmlns:a16="http://schemas.microsoft.com/office/drawing/2014/main" id="{5F31C406-9CE8-F436-F5F5-39B080119B11}"/>
+            </a:ext>
+          </a:extLst>
+        </p:cNvPr>
+        <p:cNvGrpSpPr/>
+        <p:nvPr/>
+      </p:nvGrpSpPr>
+      <p:grpSpPr>
+        <a:xfrm>
+          <a:off x="0" y="0"/>
+          <a:ext cx="0" cy="0"/>
+          <a:chOff x="0" y="0"/>
+          <a:chExt cx="0" cy="0"/>
+        </a:xfrm>
+      </p:grpSpPr>
+      <p:sp>
+        <p:nvSpPr>
+          <p:cNvPr id="3" name="TextBox 2">
+            <a:extLst>
+              <a:ext uri="{FF2B5EF4-FFF2-40B4-BE49-F238E27FC236}">
+                <a16:creationId xmlns:a16="http://schemas.microsoft.com/office/drawing/2014/main" id="{4B804128-4B0D-594C-C7E5-90E13C684755}"/>
+              </a:ext>
+            </a:extLst>
+          </p:cNvPr>
+          <p:cNvSpPr txBox="1"/>
+          <p:nvPr/>
+        </p:nvSpPr>
+        <p:spPr>
+          <a:xfrm>
+            <a:off x="217714" y="255046"/>
+            <a:ext cx="11756571" cy="355354"/>
+          </a:xfrm>
+          <a:prstGeom prst="rect">
+            <a:avLst/>
+          </a:prstGeom>
+          <a:noFill/>
+        </p:spPr>
+        <p:txBody>
+          <a:bodyPr wrap="square">
+            <a:spAutoFit/>
+          </a:bodyPr>
+          <a:lstStyle/>
+          <a:p>
+            <a:pPr>
+              <a:lnSpc>
+                <a:spcPct val="150000"/>
+              </a:lnSpc>
+              <a:buNone/>
+            </a:pPr>
+            <a:r>
+              <a:rPr kumimoji="0" lang="en-US" altLang="en-US" sz="1300" b="0" i="0" u="none" strike="noStrike" cap="none" normalizeH="0" baseline="0">
+                <a:ln>
+                  <a:noFill/>
+                </a:ln>
+                <a:solidFill>
+                  <a:schemeClr val="tx1"/>
+                </a:solidFill>
+                <a:effectLst/>
+                <a:latin typeface="Arial" panose="020B0604020202020204" pitchFamily="34" charset="0"/>
+              </a:rPr>
+              <a:t>.</a:t>
+            </a:r>
+          </a:p>
+        </p:txBody>
+      </p:sp>
+    </p:spTree>
+    <p:extLst>
+      <p:ext uri="{BB962C8B-B14F-4D97-AF65-F5344CB8AC3E}">
+        <p14:creationId xmlns:p14="http://schemas.microsoft.com/office/powerpoint/2010/main" val="3857737212"/>
+      </p:ext>
+    </p:extLst>
+  </p:cSld>
+  <p:clrMapOvr>
+    <a:masterClrMapping/>
+  </p:clrMapOvr>
+</p:sld>
+</file>
+
+<file path=ppt/slides/slide9.xml><?xml version="1.0" encoding="utf-8"?>
+<p:sld xmlns:a="http://schemas.openxmlformats.org/drawingml/2006/main" xmlns:r="http://schemas.openxmlformats.org/officeDocument/2006/relationships" xmlns:p="http://schemas.openxmlformats.org/presentationml/2006/main">
+  <p:cSld>
+    <p:spTree>
+      <p:nvGrpSpPr>
+        <p:cNvPr id="1" name="">
+          <a:extLst>
+            <a:ext uri="{FF2B5EF4-FFF2-40B4-BE49-F238E27FC236}">
+              <a16:creationId xmlns:a16="http://schemas.microsoft.com/office/drawing/2014/main" id="{63019062-1856-4736-763B-037D4CFC7F84}"/>
+            </a:ext>
+          </a:extLst>
+        </p:cNvPr>
+        <p:cNvGrpSpPr/>
+        <p:nvPr/>
+      </p:nvGrpSpPr>
+      <p:grpSpPr>
+        <a:xfrm>
+          <a:off x="0" y="0"/>
+          <a:ext cx="0" cy="0"/>
+          <a:chOff x="0" y="0"/>
+          <a:chExt cx="0" cy="0"/>
+        </a:xfrm>
+      </p:grpSpPr>
+      <p:sp>
+        <p:nvSpPr>
+          <p:cNvPr id="3" name="TextBox 2">
+            <a:extLst>
+              <a:ext uri="{FF2B5EF4-FFF2-40B4-BE49-F238E27FC236}">
+                <a16:creationId xmlns:a16="http://schemas.microsoft.com/office/drawing/2014/main" id="{DA7E4242-44F0-3662-4EAD-1D82651A8A20}"/>
+              </a:ext>
+            </a:extLst>
+          </p:cNvPr>
+          <p:cNvSpPr txBox="1"/>
+          <p:nvPr/>
+        </p:nvSpPr>
+        <p:spPr>
+          <a:xfrm>
+            <a:off x="217714" y="255046"/>
+            <a:ext cx="11756571" cy="355354"/>
+          </a:xfrm>
+          <a:prstGeom prst="rect">
+            <a:avLst/>
+          </a:prstGeom>
+          <a:noFill/>
+        </p:spPr>
+        <p:txBody>
+          <a:bodyPr wrap="square">
+            <a:spAutoFit/>
+          </a:bodyPr>
+          <a:lstStyle/>
+          <a:p>
+            <a:pPr>
+              <a:lnSpc>
+                <a:spcPct val="150000"/>
+              </a:lnSpc>
+              <a:buNone/>
+            </a:pPr>
+            <a:r>
+              <a:rPr kumimoji="0" lang="en-US" altLang="en-US" sz="1300" b="0" i="0" u="none" strike="noStrike" cap="none" normalizeH="0" baseline="0">
+                <a:ln>
+                  <a:noFill/>
+                </a:ln>
+                <a:solidFill>
+                  <a:schemeClr val="tx1"/>
+                </a:solidFill>
+                <a:effectLst/>
+                <a:latin typeface="Arial" panose="020B0604020202020204" pitchFamily="34" charset="0"/>
+              </a:rPr>
+              <a:t>.</a:t>
+            </a:r>
+          </a:p>
+        </p:txBody>
+      </p:sp>
+    </p:spTree>
+    <p:extLst>
+      <p:ext uri="{BB962C8B-B14F-4D97-AF65-F5344CB8AC3E}">
+        <p14:creationId xmlns:p14="http://schemas.microsoft.com/office/powerpoint/2010/main" val="2003862596"/>
       </p:ext>
     </p:extLst>
   </p:cSld>

</xml_diff>